<commit_message>
Prezentácia aneb "How long is this going to take?!"
</commit_message>
<xml_diff>
--- a/Identifikácia vzorov v časových radoch pre komparáciu volatility.pptx
+++ b/Identifikácia vzorov v časových radoch pre komparáciu volatility.pptx
@@ -4,11 +4,14 @@
   <p:sldMasterIdLst>
     <p:sldMasterId id="2147483660" r:id="rId1"/>
   </p:sldMasterIdLst>
+  <p:notesMasterIdLst>
+    <p:notesMasterId r:id="rId11"/>
+  </p:notesMasterIdLst>
   <p:sldIdLst>
     <p:sldId id="256" r:id="rId2"/>
     <p:sldId id="258" r:id="rId3"/>
-    <p:sldId id="259" r:id="rId4"/>
-    <p:sldId id="257" r:id="rId5"/>
+    <p:sldId id="257" r:id="rId4"/>
+    <p:sldId id="259" r:id="rId5"/>
     <p:sldId id="260" r:id="rId6"/>
     <p:sldId id="261" r:id="rId7"/>
     <p:sldId id="262" r:id="rId8"/>
@@ -1965,7 +1968,7 @@
   <dgm:whole/>
   <dgm:extLst>
     <a:ext uri="http://schemas.microsoft.com/office/drawing/2008/diagram">
-      <dsp:dataModelExt xmlns:dsp="http://schemas.microsoft.com/office/drawing/2008/diagram" relId="rId6" minVer="http://schemas.openxmlformats.org/drawingml/2006/diagram"/>
+      <dsp:dataModelExt xmlns:dsp="http://schemas.microsoft.com/office/drawing/2008/diagram" relId="rId7" minVer="http://schemas.openxmlformats.org/drawingml/2006/diagram"/>
     </a:ext>
   </dgm:extLst>
 </dgm:dataModel>
@@ -4738,6 +4741,1564 @@
 </dgm:styleDef>
 </file>
 
+<file path=ppt/notesMasters/notesMaster1.xml><?xml version="1.0" encoding="utf-8"?>
+<p:notesMaster xmlns:a="http://schemas.openxmlformats.org/drawingml/2006/main" xmlns:r="http://schemas.openxmlformats.org/officeDocument/2006/relationships" xmlns:p="http://schemas.openxmlformats.org/presentationml/2006/main">
+  <p:cSld>
+    <p:bg>
+      <p:bgRef idx="1001">
+        <a:schemeClr val="bg1"/>
+      </p:bgRef>
+    </p:bg>
+    <p:spTree>
+      <p:nvGrpSpPr>
+        <p:cNvPr id="1" name=""/>
+        <p:cNvGrpSpPr/>
+        <p:nvPr/>
+      </p:nvGrpSpPr>
+      <p:grpSpPr>
+        <a:xfrm>
+          <a:off x="0" y="0"/>
+          <a:ext cx="0" cy="0"/>
+          <a:chOff x="0" y="0"/>
+          <a:chExt cx="0" cy="0"/>
+        </a:xfrm>
+      </p:grpSpPr>
+      <p:sp>
+        <p:nvSpPr>
+          <p:cNvPr id="2" name="Zástupný objekt pre hlavičku 1"/>
+          <p:cNvSpPr>
+            <a:spLocks noGrp="1"/>
+          </p:cNvSpPr>
+          <p:nvPr>
+            <p:ph type="hdr" sz="quarter"/>
+          </p:nvPr>
+        </p:nvSpPr>
+        <p:spPr>
+          <a:xfrm>
+            <a:off x="0" y="0"/>
+            <a:ext cx="2971800" cy="458788"/>
+          </a:xfrm>
+          <a:prstGeom prst="rect">
+            <a:avLst/>
+          </a:prstGeom>
+        </p:spPr>
+        <p:txBody>
+          <a:bodyPr vert="horz" lIns="91440" tIns="45720" rIns="91440" bIns="45720" rtlCol="0"/>
+          <a:lstStyle>
+            <a:lvl1pPr algn="l">
+              <a:defRPr sz="1200"/>
+            </a:lvl1pPr>
+          </a:lstStyle>
+          <a:p>
+            <a:endParaRPr lang="sk-SK"/>
+          </a:p>
+        </p:txBody>
+      </p:sp>
+      <p:sp>
+        <p:nvSpPr>
+          <p:cNvPr id="3" name="Zástupný objekt pre dátum 2"/>
+          <p:cNvSpPr>
+            <a:spLocks noGrp="1"/>
+          </p:cNvSpPr>
+          <p:nvPr>
+            <p:ph type="dt" idx="1"/>
+          </p:nvPr>
+        </p:nvSpPr>
+        <p:spPr>
+          <a:xfrm>
+            <a:off x="3884613" y="0"/>
+            <a:ext cx="2971800" cy="458788"/>
+          </a:xfrm>
+          <a:prstGeom prst="rect">
+            <a:avLst/>
+          </a:prstGeom>
+        </p:spPr>
+        <p:txBody>
+          <a:bodyPr vert="horz" lIns="91440" tIns="45720" rIns="91440" bIns="45720" rtlCol="0"/>
+          <a:lstStyle>
+            <a:lvl1pPr algn="r">
+              <a:defRPr sz="1200"/>
+            </a:lvl1pPr>
+          </a:lstStyle>
+          <a:p>
+            <a:fld id="{AD9B504B-8E04-47AE-BBD5-0260BCE63BC0}" type="datetimeFigureOut">
+              <a:rPr lang="sk-SK" smtClean="0"/>
+              <a:t>21. 6. 2026</a:t>
+            </a:fld>
+            <a:endParaRPr lang="sk-SK"/>
+          </a:p>
+        </p:txBody>
+      </p:sp>
+      <p:sp>
+        <p:nvSpPr>
+          <p:cNvPr id="4" name="Zástupný objekt pre obrázok snímky 3"/>
+          <p:cNvSpPr>
+            <a:spLocks noGrp="1" noRot="1" noChangeAspect="1"/>
+          </p:cNvSpPr>
+          <p:nvPr>
+            <p:ph type="sldImg" idx="2"/>
+          </p:nvPr>
+        </p:nvSpPr>
+        <p:spPr>
+          <a:xfrm>
+            <a:off x="685800" y="1143000"/>
+            <a:ext cx="5486400" cy="3086100"/>
+          </a:xfrm>
+          <a:prstGeom prst="rect">
+            <a:avLst/>
+          </a:prstGeom>
+          <a:noFill/>
+          <a:ln w="12700">
+            <a:solidFill>
+              <a:prstClr val="black"/>
+            </a:solidFill>
+          </a:ln>
+        </p:spPr>
+        <p:txBody>
+          <a:bodyPr vert="horz" lIns="91440" tIns="45720" rIns="91440" bIns="45720" rtlCol="0" anchor="ctr"/>
+          <a:lstStyle/>
+          <a:p>
+            <a:endParaRPr lang="sk-SK"/>
+          </a:p>
+        </p:txBody>
+      </p:sp>
+      <p:sp>
+        <p:nvSpPr>
+          <p:cNvPr id="5" name="Zástupný objekt pre poznámky 4"/>
+          <p:cNvSpPr>
+            <a:spLocks noGrp="1"/>
+          </p:cNvSpPr>
+          <p:nvPr>
+            <p:ph type="body" sz="quarter" idx="3"/>
+          </p:nvPr>
+        </p:nvSpPr>
+        <p:spPr>
+          <a:xfrm>
+            <a:off x="685800" y="4400550"/>
+            <a:ext cx="5486400" cy="3600450"/>
+          </a:xfrm>
+          <a:prstGeom prst="rect">
+            <a:avLst/>
+          </a:prstGeom>
+        </p:spPr>
+        <p:txBody>
+          <a:bodyPr vert="horz" lIns="91440" tIns="45720" rIns="91440" bIns="45720" rtlCol="0"/>
+          <a:lstStyle/>
+          <a:p>
+            <a:pPr lvl="0"/>
+            <a:r>
+              <a:rPr lang="sk-SK"/>
+              <a:t>Kliknite sem a upravte štýly predlohy textu</a:t>
+            </a:r>
+          </a:p>
+          <a:p>
+            <a:pPr lvl="1"/>
+            <a:r>
+              <a:rPr lang="sk-SK"/>
+              <a:t>Druhá úroveň</a:t>
+            </a:r>
+          </a:p>
+          <a:p>
+            <a:pPr lvl="2"/>
+            <a:r>
+              <a:rPr lang="sk-SK"/>
+              <a:t>Tretia úroveň</a:t>
+            </a:r>
+          </a:p>
+          <a:p>
+            <a:pPr lvl="3"/>
+            <a:r>
+              <a:rPr lang="sk-SK"/>
+              <a:t>Štvrtá úroveň</a:t>
+            </a:r>
+          </a:p>
+          <a:p>
+            <a:pPr lvl="4"/>
+            <a:r>
+              <a:rPr lang="sk-SK"/>
+              <a:t>Piata úroveň</a:t>
+            </a:r>
+          </a:p>
+        </p:txBody>
+      </p:sp>
+      <p:sp>
+        <p:nvSpPr>
+          <p:cNvPr id="6" name="Zástupný objekt pre pätu 5"/>
+          <p:cNvSpPr>
+            <a:spLocks noGrp="1"/>
+          </p:cNvSpPr>
+          <p:nvPr>
+            <p:ph type="ftr" sz="quarter" idx="4"/>
+          </p:nvPr>
+        </p:nvSpPr>
+        <p:spPr>
+          <a:xfrm>
+            <a:off x="0" y="8685213"/>
+            <a:ext cx="2971800" cy="458787"/>
+          </a:xfrm>
+          <a:prstGeom prst="rect">
+            <a:avLst/>
+          </a:prstGeom>
+        </p:spPr>
+        <p:txBody>
+          <a:bodyPr vert="horz" lIns="91440" tIns="45720" rIns="91440" bIns="45720" rtlCol="0" anchor="b"/>
+          <a:lstStyle>
+            <a:lvl1pPr algn="l">
+              <a:defRPr sz="1200"/>
+            </a:lvl1pPr>
+          </a:lstStyle>
+          <a:p>
+            <a:endParaRPr lang="sk-SK"/>
+          </a:p>
+        </p:txBody>
+      </p:sp>
+      <p:sp>
+        <p:nvSpPr>
+          <p:cNvPr id="7" name="Zástupný objekt pre číslo snímky 6"/>
+          <p:cNvSpPr>
+            <a:spLocks noGrp="1"/>
+          </p:cNvSpPr>
+          <p:nvPr>
+            <p:ph type="sldNum" sz="quarter" idx="5"/>
+          </p:nvPr>
+        </p:nvSpPr>
+        <p:spPr>
+          <a:xfrm>
+            <a:off x="3884613" y="8685213"/>
+            <a:ext cx="2971800" cy="458787"/>
+          </a:xfrm>
+          <a:prstGeom prst="rect">
+            <a:avLst/>
+          </a:prstGeom>
+        </p:spPr>
+        <p:txBody>
+          <a:bodyPr vert="horz" lIns="91440" tIns="45720" rIns="91440" bIns="45720" rtlCol="0" anchor="b"/>
+          <a:lstStyle>
+            <a:lvl1pPr algn="r">
+              <a:defRPr sz="1200"/>
+            </a:lvl1pPr>
+          </a:lstStyle>
+          <a:p>
+            <a:fld id="{720C6227-A214-42BB-84EB-9C7415895DDE}" type="slidenum">
+              <a:rPr lang="sk-SK" smtClean="0"/>
+              <a:t>‹#›</a:t>
+            </a:fld>
+            <a:endParaRPr lang="sk-SK"/>
+          </a:p>
+        </p:txBody>
+      </p:sp>
+    </p:spTree>
+    <p:extLst>
+      <p:ext uri="{BB962C8B-B14F-4D97-AF65-F5344CB8AC3E}">
+        <p14:creationId xmlns:p14="http://schemas.microsoft.com/office/powerpoint/2010/main" val="4120199202"/>
+      </p:ext>
+    </p:extLst>
+  </p:cSld>
+  <p:clrMap bg1="lt1" tx1="dk1" bg2="lt2" tx2="dk2" accent1="accent1" accent2="accent2" accent3="accent3" accent4="accent4" accent5="accent5" accent6="accent6" hlink="hlink" folHlink="folHlink"/>
+  <p:notesStyle>
+    <a:lvl1pPr marL="0" algn="l" defTabSz="914400" rtl="0" eaLnBrk="1" latinLnBrk="0" hangingPunct="1">
+      <a:defRPr sz="1200" kern="1200">
+        <a:solidFill>
+          <a:schemeClr val="tx1"/>
+        </a:solidFill>
+        <a:latin typeface="+mn-lt"/>
+        <a:ea typeface="+mn-ea"/>
+        <a:cs typeface="+mn-cs"/>
+      </a:defRPr>
+    </a:lvl1pPr>
+    <a:lvl2pPr marL="457200" algn="l" defTabSz="914400" rtl="0" eaLnBrk="1" latinLnBrk="0" hangingPunct="1">
+      <a:defRPr sz="1200" kern="1200">
+        <a:solidFill>
+          <a:schemeClr val="tx1"/>
+        </a:solidFill>
+        <a:latin typeface="+mn-lt"/>
+        <a:ea typeface="+mn-ea"/>
+        <a:cs typeface="+mn-cs"/>
+      </a:defRPr>
+    </a:lvl2pPr>
+    <a:lvl3pPr marL="914400" algn="l" defTabSz="914400" rtl="0" eaLnBrk="1" latinLnBrk="0" hangingPunct="1">
+      <a:defRPr sz="1200" kern="1200">
+        <a:solidFill>
+          <a:schemeClr val="tx1"/>
+        </a:solidFill>
+        <a:latin typeface="+mn-lt"/>
+        <a:ea typeface="+mn-ea"/>
+        <a:cs typeface="+mn-cs"/>
+      </a:defRPr>
+    </a:lvl3pPr>
+    <a:lvl4pPr marL="1371600" algn="l" defTabSz="914400" rtl="0" eaLnBrk="1" latinLnBrk="0" hangingPunct="1">
+      <a:defRPr sz="1200" kern="1200">
+        <a:solidFill>
+          <a:schemeClr val="tx1"/>
+        </a:solidFill>
+        <a:latin typeface="+mn-lt"/>
+        <a:ea typeface="+mn-ea"/>
+        <a:cs typeface="+mn-cs"/>
+      </a:defRPr>
+    </a:lvl4pPr>
+    <a:lvl5pPr marL="1828800" algn="l" defTabSz="914400" rtl="0" eaLnBrk="1" latinLnBrk="0" hangingPunct="1">
+      <a:defRPr sz="1200" kern="1200">
+        <a:solidFill>
+          <a:schemeClr val="tx1"/>
+        </a:solidFill>
+        <a:latin typeface="+mn-lt"/>
+        <a:ea typeface="+mn-ea"/>
+        <a:cs typeface="+mn-cs"/>
+      </a:defRPr>
+    </a:lvl5pPr>
+    <a:lvl6pPr marL="2286000" algn="l" defTabSz="914400" rtl="0" eaLnBrk="1" latinLnBrk="0" hangingPunct="1">
+      <a:defRPr sz="1200" kern="1200">
+        <a:solidFill>
+          <a:schemeClr val="tx1"/>
+        </a:solidFill>
+        <a:latin typeface="+mn-lt"/>
+        <a:ea typeface="+mn-ea"/>
+        <a:cs typeface="+mn-cs"/>
+      </a:defRPr>
+    </a:lvl6pPr>
+    <a:lvl7pPr marL="2743200" algn="l" defTabSz="914400" rtl="0" eaLnBrk="1" latinLnBrk="0" hangingPunct="1">
+      <a:defRPr sz="1200" kern="1200">
+        <a:solidFill>
+          <a:schemeClr val="tx1"/>
+        </a:solidFill>
+        <a:latin typeface="+mn-lt"/>
+        <a:ea typeface="+mn-ea"/>
+        <a:cs typeface="+mn-cs"/>
+      </a:defRPr>
+    </a:lvl7pPr>
+    <a:lvl8pPr marL="3200400" algn="l" defTabSz="914400" rtl="0" eaLnBrk="1" latinLnBrk="0" hangingPunct="1">
+      <a:defRPr sz="1200" kern="1200">
+        <a:solidFill>
+          <a:schemeClr val="tx1"/>
+        </a:solidFill>
+        <a:latin typeface="+mn-lt"/>
+        <a:ea typeface="+mn-ea"/>
+        <a:cs typeface="+mn-cs"/>
+      </a:defRPr>
+    </a:lvl8pPr>
+    <a:lvl9pPr marL="3657600" algn="l" defTabSz="914400" rtl="0" eaLnBrk="1" latinLnBrk="0" hangingPunct="1">
+      <a:defRPr sz="1200" kern="1200">
+        <a:solidFill>
+          <a:schemeClr val="tx1"/>
+        </a:solidFill>
+        <a:latin typeface="+mn-lt"/>
+        <a:ea typeface="+mn-ea"/>
+        <a:cs typeface="+mn-cs"/>
+      </a:defRPr>
+    </a:lvl9pPr>
+  </p:notesStyle>
+</p:notesMaster>
+</file>
+
+<file path=ppt/notesSlides/notesSlide1.xml><?xml version="1.0" encoding="utf-8"?>
+<p:notes xmlns:a="http://schemas.openxmlformats.org/drawingml/2006/main" xmlns:r="http://schemas.openxmlformats.org/officeDocument/2006/relationships" xmlns:p="http://schemas.openxmlformats.org/presentationml/2006/main">
+  <p:cSld>
+    <p:spTree>
+      <p:nvGrpSpPr>
+        <p:cNvPr id="1" name=""/>
+        <p:cNvGrpSpPr/>
+        <p:nvPr/>
+      </p:nvGrpSpPr>
+      <p:grpSpPr>
+        <a:xfrm>
+          <a:off x="0" y="0"/>
+          <a:ext cx="0" cy="0"/>
+          <a:chOff x="0" y="0"/>
+          <a:chExt cx="0" cy="0"/>
+        </a:xfrm>
+      </p:grpSpPr>
+      <p:sp>
+        <p:nvSpPr>
+          <p:cNvPr id="2" name="Zástupný objekt pre obrázok snímky 1"/>
+          <p:cNvSpPr>
+            <a:spLocks noGrp="1" noRot="1" noChangeAspect="1"/>
+          </p:cNvSpPr>
+          <p:nvPr>
+            <p:ph type="sldImg"/>
+          </p:nvPr>
+        </p:nvSpPr>
+        <p:spPr/>
+      </p:sp>
+      <p:sp>
+        <p:nvSpPr>
+          <p:cNvPr id="3" name="Zástupný objekt pre poznámky 2"/>
+          <p:cNvSpPr>
+            <a:spLocks noGrp="1"/>
+          </p:cNvSpPr>
+          <p:nvPr>
+            <p:ph type="body" idx="1"/>
+          </p:nvPr>
+        </p:nvSpPr>
+        <p:spPr/>
+        <p:txBody>
+          <a:bodyPr/>
+          <a:lstStyle/>
+          <a:p>
+            <a:r>
+              <a:rPr lang="sk-SK" dirty="0"/>
+              <a:t>Vážená komisia, rád by som Vám predstavil môj koncept dizertačnej práce s názvom:</a:t>
+            </a:r>
+          </a:p>
+        </p:txBody>
+      </p:sp>
+      <p:sp>
+        <p:nvSpPr>
+          <p:cNvPr id="4" name="Zástupný objekt pre číslo snímky 3"/>
+          <p:cNvSpPr>
+            <a:spLocks noGrp="1"/>
+          </p:cNvSpPr>
+          <p:nvPr>
+            <p:ph type="sldNum" sz="quarter" idx="5"/>
+          </p:nvPr>
+        </p:nvSpPr>
+        <p:spPr/>
+        <p:txBody>
+          <a:bodyPr/>
+          <a:lstStyle/>
+          <a:p>
+            <a:fld id="{720C6227-A214-42BB-84EB-9C7415895DDE}" type="slidenum">
+              <a:rPr lang="sk-SK" smtClean="0"/>
+              <a:t>1</a:t>
+            </a:fld>
+            <a:endParaRPr lang="sk-SK"/>
+          </a:p>
+        </p:txBody>
+      </p:sp>
+    </p:spTree>
+    <p:extLst>
+      <p:ext uri="{BB962C8B-B14F-4D97-AF65-F5344CB8AC3E}">
+        <p14:creationId xmlns:p14="http://schemas.microsoft.com/office/powerpoint/2010/main" val="3822607468"/>
+      </p:ext>
+    </p:extLst>
+  </p:cSld>
+  <p:clrMapOvr>
+    <a:masterClrMapping/>
+  </p:clrMapOvr>
+</p:notes>
+</file>
+
+<file path=ppt/notesSlides/notesSlide2.xml><?xml version="1.0" encoding="utf-8"?>
+<p:notes xmlns:a="http://schemas.openxmlformats.org/drawingml/2006/main" xmlns:r="http://schemas.openxmlformats.org/officeDocument/2006/relationships" xmlns:p="http://schemas.openxmlformats.org/presentationml/2006/main">
+  <p:cSld>
+    <p:spTree>
+      <p:nvGrpSpPr>
+        <p:cNvPr id="1" name=""/>
+        <p:cNvGrpSpPr/>
+        <p:nvPr/>
+      </p:nvGrpSpPr>
+      <p:grpSpPr>
+        <a:xfrm>
+          <a:off x="0" y="0"/>
+          <a:ext cx="0" cy="0"/>
+          <a:chOff x="0" y="0"/>
+          <a:chExt cx="0" cy="0"/>
+        </a:xfrm>
+      </p:grpSpPr>
+      <p:sp>
+        <p:nvSpPr>
+          <p:cNvPr id="2" name="Zástupný objekt pre obrázok snímky 1"/>
+          <p:cNvSpPr>
+            <a:spLocks noGrp="1" noRot="1" noChangeAspect="1"/>
+          </p:cNvSpPr>
+          <p:nvPr>
+            <p:ph type="sldImg"/>
+          </p:nvPr>
+        </p:nvSpPr>
+        <p:spPr/>
+      </p:sp>
+      <p:sp>
+        <p:nvSpPr>
+          <p:cNvPr id="3" name="Zástupný objekt pre poznámky 2"/>
+          <p:cNvSpPr>
+            <a:spLocks noGrp="1"/>
+          </p:cNvSpPr>
+          <p:nvPr>
+            <p:ph type="body" idx="1"/>
+          </p:nvPr>
+        </p:nvSpPr>
+        <p:spPr/>
+        <p:txBody>
+          <a:bodyPr/>
+          <a:lstStyle/>
+          <a:p>
+            <a:r>
+              <a:rPr lang="en-US" dirty="0" err="1"/>
+              <a:t>Definova</a:t>
+            </a:r>
+            <a:r>
+              <a:rPr lang="sk-SK" dirty="0"/>
+              <a:t>ť cieľ a načrtnúť metodiku.</a:t>
+            </a:r>
+          </a:p>
+        </p:txBody>
+      </p:sp>
+      <p:sp>
+        <p:nvSpPr>
+          <p:cNvPr id="4" name="Zástupný objekt pre číslo snímky 3"/>
+          <p:cNvSpPr>
+            <a:spLocks noGrp="1"/>
+          </p:cNvSpPr>
+          <p:nvPr>
+            <p:ph type="sldNum" sz="quarter" idx="5"/>
+          </p:nvPr>
+        </p:nvSpPr>
+        <p:spPr/>
+        <p:txBody>
+          <a:bodyPr/>
+          <a:lstStyle/>
+          <a:p>
+            <a:fld id="{720C6227-A214-42BB-84EB-9C7415895DDE}" type="slidenum">
+              <a:rPr lang="sk-SK" smtClean="0"/>
+              <a:t>2</a:t>
+            </a:fld>
+            <a:endParaRPr lang="sk-SK"/>
+          </a:p>
+        </p:txBody>
+      </p:sp>
+    </p:spTree>
+    <p:extLst>
+      <p:ext uri="{BB962C8B-B14F-4D97-AF65-F5344CB8AC3E}">
+        <p14:creationId xmlns:p14="http://schemas.microsoft.com/office/powerpoint/2010/main" val="3795803306"/>
+      </p:ext>
+    </p:extLst>
+  </p:cSld>
+  <p:clrMapOvr>
+    <a:masterClrMapping/>
+  </p:clrMapOvr>
+</p:notes>
+</file>
+
+<file path=ppt/notesSlides/notesSlide3.xml><?xml version="1.0" encoding="utf-8"?>
+<p:notes xmlns:a="http://schemas.openxmlformats.org/drawingml/2006/main" xmlns:r="http://schemas.openxmlformats.org/officeDocument/2006/relationships" xmlns:p="http://schemas.openxmlformats.org/presentationml/2006/main">
+  <p:cSld>
+    <p:spTree>
+      <p:nvGrpSpPr>
+        <p:cNvPr id="1" name=""/>
+        <p:cNvGrpSpPr/>
+        <p:nvPr/>
+      </p:nvGrpSpPr>
+      <p:grpSpPr>
+        <a:xfrm>
+          <a:off x="0" y="0"/>
+          <a:ext cx="0" cy="0"/>
+          <a:chOff x="0" y="0"/>
+          <a:chExt cx="0" cy="0"/>
+        </a:xfrm>
+      </p:grpSpPr>
+      <p:sp>
+        <p:nvSpPr>
+          <p:cNvPr id="2" name="Zástupný objekt pre obrázok snímky 1"/>
+          <p:cNvSpPr>
+            <a:spLocks noGrp="1" noRot="1" noChangeAspect="1"/>
+          </p:cNvSpPr>
+          <p:nvPr>
+            <p:ph type="sldImg"/>
+          </p:nvPr>
+        </p:nvSpPr>
+        <p:spPr/>
+      </p:sp>
+      <p:sp>
+        <p:nvSpPr>
+          <p:cNvPr id="3" name="Zástupný objekt pre poznámky 2"/>
+          <p:cNvSpPr>
+            <a:spLocks noGrp="1"/>
+          </p:cNvSpPr>
+          <p:nvPr>
+            <p:ph type="body" idx="1"/>
+          </p:nvPr>
+        </p:nvSpPr>
+        <p:spPr/>
+        <p:txBody>
+          <a:bodyPr/>
+          <a:lstStyle/>
+          <a:p>
+            <a:r>
+              <a:rPr lang="sk-SK" dirty="0"/>
+              <a:t>Popísať analýzu súčasného stavu a vyplývajúce medzery vo výskume.</a:t>
+            </a:r>
+          </a:p>
+          <a:p>
+            <a:endParaRPr lang="sk-SK" dirty="0"/>
+          </a:p>
+          <a:p>
+            <a:r>
+              <a:rPr lang="sk-SK" dirty="0"/>
+              <a:t>Medzery:</a:t>
+            </a:r>
+          </a:p>
+          <a:p>
+            <a:r>
+              <a:rPr lang="sk-SK" sz="1200" kern="1200" dirty="0">
+                <a:solidFill>
+                  <a:schemeClr val="tx1"/>
+                </a:solidFill>
+                <a:effectLst/>
+                <a:latin typeface="+mn-lt"/>
+                <a:ea typeface="+mn-ea"/>
+                <a:cs typeface="+mn-cs"/>
+              </a:rPr>
+              <a:t>Z analýzy súčasného stavu je zrejmé, že metódy umelej inteligencie nielen trpia nízkou interpretovateľnosťou, ale ani konzistentne neprekonávajú štandardné ekonometrické modely. Preto je potrebný ďalší výskum. Doterajší výskum sa sústredí najmä na modelovanie globálnych trhových indexov ako SP500, STOXX600a SSE </a:t>
+            </a:r>
+            <a:r>
+              <a:rPr lang="sk-SK" sz="1200" kern="1200" dirty="0" err="1">
+                <a:solidFill>
+                  <a:schemeClr val="tx1"/>
+                </a:solidFill>
+                <a:effectLst/>
+                <a:latin typeface="+mn-lt"/>
+                <a:ea typeface="+mn-ea"/>
+                <a:cs typeface="+mn-cs"/>
+              </a:rPr>
+              <a:t>Composite</a:t>
+            </a:r>
+            <a:r>
+              <a:rPr lang="sk-SK" sz="1200" kern="1200" dirty="0">
+                <a:solidFill>
+                  <a:schemeClr val="tx1"/>
+                </a:solidFill>
+                <a:effectLst/>
+                <a:latin typeface="+mn-lt"/>
+                <a:ea typeface="+mn-ea"/>
+                <a:cs typeface="+mn-cs"/>
+              </a:rPr>
+              <a:t>, pričom chýba podrobná analýza konkrétnych firiem naprieč USA, Európou a Čínou. Taktiež spoľahlivosť zdrojov denných cien je dosť neprebádané teritórium. Vyhodnotenie výsledkov a porovnanie rôznych zdrojov dát preto prinesie nové poznatky užitočné pre budúci výskum.</a:t>
+            </a:r>
+            <a:endParaRPr lang="sk-SK" dirty="0"/>
+          </a:p>
+        </p:txBody>
+      </p:sp>
+      <p:sp>
+        <p:nvSpPr>
+          <p:cNvPr id="4" name="Zástupný objekt pre číslo snímky 3"/>
+          <p:cNvSpPr>
+            <a:spLocks noGrp="1"/>
+          </p:cNvSpPr>
+          <p:nvPr>
+            <p:ph type="sldNum" sz="quarter" idx="5"/>
+          </p:nvPr>
+        </p:nvSpPr>
+        <p:spPr/>
+        <p:txBody>
+          <a:bodyPr/>
+          <a:lstStyle/>
+          <a:p>
+            <a:fld id="{720C6227-A214-42BB-84EB-9C7415895DDE}" type="slidenum">
+              <a:rPr lang="sk-SK" smtClean="0"/>
+              <a:t>3</a:t>
+            </a:fld>
+            <a:endParaRPr lang="sk-SK"/>
+          </a:p>
+        </p:txBody>
+      </p:sp>
+    </p:spTree>
+    <p:extLst>
+      <p:ext uri="{BB962C8B-B14F-4D97-AF65-F5344CB8AC3E}">
+        <p14:creationId xmlns:p14="http://schemas.microsoft.com/office/powerpoint/2010/main" val="635978654"/>
+      </p:ext>
+    </p:extLst>
+  </p:cSld>
+  <p:clrMapOvr>
+    <a:masterClrMapping/>
+  </p:clrMapOvr>
+</p:notes>
+</file>
+
+<file path=ppt/notesSlides/notesSlide4.xml><?xml version="1.0" encoding="utf-8"?>
+<p:notes xmlns:a="http://schemas.openxmlformats.org/drawingml/2006/main" xmlns:r="http://schemas.openxmlformats.org/officeDocument/2006/relationships" xmlns:p="http://schemas.openxmlformats.org/presentationml/2006/main">
+  <p:cSld>
+    <p:spTree>
+      <p:nvGrpSpPr>
+        <p:cNvPr id="1" name=""/>
+        <p:cNvGrpSpPr/>
+        <p:nvPr/>
+      </p:nvGrpSpPr>
+      <p:grpSpPr>
+        <a:xfrm>
+          <a:off x="0" y="0"/>
+          <a:ext cx="0" cy="0"/>
+          <a:chOff x="0" y="0"/>
+          <a:chExt cx="0" cy="0"/>
+        </a:xfrm>
+      </p:grpSpPr>
+      <p:sp>
+        <p:nvSpPr>
+          <p:cNvPr id="2" name="Zástupný objekt pre obrázok snímky 1"/>
+          <p:cNvSpPr>
+            <a:spLocks noGrp="1" noRot="1" noChangeAspect="1"/>
+          </p:cNvSpPr>
+          <p:nvPr>
+            <p:ph type="sldImg"/>
+          </p:nvPr>
+        </p:nvSpPr>
+        <p:spPr/>
+      </p:sp>
+      <p:sp>
+        <p:nvSpPr>
+          <p:cNvPr id="3" name="Zástupný objekt pre poznámky 2"/>
+          <p:cNvSpPr>
+            <a:spLocks noGrp="1"/>
+          </p:cNvSpPr>
+          <p:nvPr>
+            <p:ph type="body" idx="1"/>
+          </p:nvPr>
+        </p:nvSpPr>
+        <p:spPr/>
+        <p:txBody>
+          <a:bodyPr/>
+          <a:lstStyle/>
+          <a:p>
+            <a:r>
+              <a:rPr lang="sk-SK" dirty="0"/>
+              <a:t>Z analýzy je zrejmé, že obdobie pandémie viedlo k zvýšenej volatilite trhov, pričom dynamika volatility sa medzi trhmi líši. </a:t>
+            </a:r>
+          </a:p>
+        </p:txBody>
+      </p:sp>
+      <p:sp>
+        <p:nvSpPr>
+          <p:cNvPr id="4" name="Zástupný objekt pre číslo snímky 3"/>
+          <p:cNvSpPr>
+            <a:spLocks noGrp="1"/>
+          </p:cNvSpPr>
+          <p:nvPr>
+            <p:ph type="sldNum" sz="quarter" idx="5"/>
+          </p:nvPr>
+        </p:nvSpPr>
+        <p:spPr/>
+        <p:txBody>
+          <a:bodyPr/>
+          <a:lstStyle/>
+          <a:p>
+            <a:fld id="{720C6227-A214-42BB-84EB-9C7415895DDE}" type="slidenum">
+              <a:rPr lang="sk-SK" smtClean="0"/>
+              <a:t>4</a:t>
+            </a:fld>
+            <a:endParaRPr lang="sk-SK"/>
+          </a:p>
+        </p:txBody>
+      </p:sp>
+    </p:spTree>
+    <p:extLst>
+      <p:ext uri="{BB962C8B-B14F-4D97-AF65-F5344CB8AC3E}">
+        <p14:creationId xmlns:p14="http://schemas.microsoft.com/office/powerpoint/2010/main" val="528411888"/>
+      </p:ext>
+    </p:extLst>
+  </p:cSld>
+  <p:clrMapOvr>
+    <a:masterClrMapping/>
+  </p:clrMapOvr>
+</p:notes>
+</file>
+
+<file path=ppt/notesSlides/notesSlide5.xml><?xml version="1.0" encoding="utf-8"?>
+<p:notes xmlns:a="http://schemas.openxmlformats.org/drawingml/2006/main" xmlns:r="http://schemas.openxmlformats.org/officeDocument/2006/relationships" xmlns:p="http://schemas.openxmlformats.org/presentationml/2006/main">
+  <p:cSld>
+    <p:spTree>
+      <p:nvGrpSpPr>
+        <p:cNvPr id="1" name=""/>
+        <p:cNvGrpSpPr/>
+        <p:nvPr/>
+      </p:nvGrpSpPr>
+      <p:grpSpPr>
+        <a:xfrm>
+          <a:off x="0" y="0"/>
+          <a:ext cx="0" cy="0"/>
+          <a:chOff x="0" y="0"/>
+          <a:chExt cx="0" cy="0"/>
+        </a:xfrm>
+      </p:grpSpPr>
+      <p:sp>
+        <p:nvSpPr>
+          <p:cNvPr id="2" name="Zástupný objekt pre obrázok snímky 1"/>
+          <p:cNvSpPr>
+            <a:spLocks noGrp="1" noRot="1" noChangeAspect="1"/>
+          </p:cNvSpPr>
+          <p:nvPr>
+            <p:ph type="sldImg"/>
+          </p:nvPr>
+        </p:nvSpPr>
+        <p:spPr/>
+      </p:sp>
+      <p:sp>
+        <p:nvSpPr>
+          <p:cNvPr id="3" name="Zástupný objekt pre poznámky 2"/>
+          <p:cNvSpPr>
+            <a:spLocks noGrp="1"/>
+          </p:cNvSpPr>
+          <p:nvPr>
+            <p:ph type="body" idx="1"/>
+          </p:nvPr>
+        </p:nvSpPr>
+        <p:spPr/>
+        <p:txBody>
+          <a:bodyPr/>
+          <a:lstStyle/>
+          <a:p>
+            <a:r>
+              <a:rPr lang="sk-SK" dirty="0"/>
+              <a:t>Podrobnejšie popísať navrhovanú metodiku výskumu.</a:t>
+            </a:r>
+          </a:p>
+        </p:txBody>
+      </p:sp>
+      <p:sp>
+        <p:nvSpPr>
+          <p:cNvPr id="4" name="Zástupný objekt pre číslo snímky 3"/>
+          <p:cNvSpPr>
+            <a:spLocks noGrp="1"/>
+          </p:cNvSpPr>
+          <p:nvPr>
+            <p:ph type="sldNum" sz="quarter" idx="5"/>
+          </p:nvPr>
+        </p:nvSpPr>
+        <p:spPr/>
+        <p:txBody>
+          <a:bodyPr/>
+          <a:lstStyle/>
+          <a:p>
+            <a:fld id="{720C6227-A214-42BB-84EB-9C7415895DDE}" type="slidenum">
+              <a:rPr lang="sk-SK" smtClean="0"/>
+              <a:t>5</a:t>
+            </a:fld>
+            <a:endParaRPr lang="sk-SK"/>
+          </a:p>
+        </p:txBody>
+      </p:sp>
+    </p:spTree>
+    <p:extLst>
+      <p:ext uri="{BB962C8B-B14F-4D97-AF65-F5344CB8AC3E}">
+        <p14:creationId xmlns:p14="http://schemas.microsoft.com/office/powerpoint/2010/main" val="433587241"/>
+      </p:ext>
+    </p:extLst>
+  </p:cSld>
+  <p:clrMapOvr>
+    <a:masterClrMapping/>
+  </p:clrMapOvr>
+</p:notes>
+</file>
+
+<file path=ppt/notesSlides/notesSlide6.xml><?xml version="1.0" encoding="utf-8"?>
+<p:notes xmlns:a="http://schemas.openxmlformats.org/drawingml/2006/main" xmlns:r="http://schemas.openxmlformats.org/officeDocument/2006/relationships" xmlns:p="http://schemas.openxmlformats.org/presentationml/2006/main">
+  <p:cSld>
+    <p:spTree>
+      <p:nvGrpSpPr>
+        <p:cNvPr id="1" name=""/>
+        <p:cNvGrpSpPr/>
+        <p:nvPr/>
+      </p:nvGrpSpPr>
+      <p:grpSpPr>
+        <a:xfrm>
+          <a:off x="0" y="0"/>
+          <a:ext cx="0" cy="0"/>
+          <a:chOff x="0" y="0"/>
+          <a:chExt cx="0" cy="0"/>
+        </a:xfrm>
+      </p:grpSpPr>
+      <p:sp>
+        <p:nvSpPr>
+          <p:cNvPr id="2" name="Zástupný objekt pre obrázok snímky 1"/>
+          <p:cNvSpPr>
+            <a:spLocks noGrp="1" noRot="1" noChangeAspect="1"/>
+          </p:cNvSpPr>
+          <p:nvPr>
+            <p:ph type="sldImg"/>
+          </p:nvPr>
+        </p:nvSpPr>
+        <p:spPr/>
+      </p:sp>
+      <p:sp>
+        <p:nvSpPr>
+          <p:cNvPr id="3" name="Zástupný objekt pre poznámky 2"/>
+          <p:cNvSpPr>
+            <a:spLocks noGrp="1"/>
+          </p:cNvSpPr>
+          <p:nvPr>
+            <p:ph type="body" idx="1"/>
+          </p:nvPr>
+        </p:nvSpPr>
+        <p:spPr/>
+        <p:txBody>
+          <a:bodyPr/>
+          <a:lstStyle/>
+          <a:p>
+            <a:r>
+              <a:rPr lang="sk-SK" dirty="0"/>
+              <a:t>Popísať získanie dát firiem, rozdelenie do sektorov a porovnanie zdrojov dát. Uviesť rozdelenie na základe období.</a:t>
+            </a:r>
+          </a:p>
+          <a:p>
+            <a:endParaRPr lang="sk-SK" dirty="0"/>
+          </a:p>
+          <a:p>
+            <a:r>
+              <a:rPr lang="sk-SK" dirty="0"/>
+              <a:t>Vybraná firma musí mať denné dáta počas celého obdobia, neobsahuje veľa chýbajúcich dát a patrí medzi veľké firmy s vysokou likviditou. Firmy budú vybrané naprieč viacerými sektormi, napríklad: IT, Financie, Priemysel, Spotrebný tovar, Energie, Zdravotníctvo. Firmy budú taktiež zvolené na základe obsiahnutia v globálnych trhových indexoch ako SP500, STOXX600 a SSE </a:t>
+            </a:r>
+            <a:r>
+              <a:rPr lang="sk-SK" dirty="0" err="1"/>
+              <a:t>Composite</a:t>
+            </a:r>
+            <a:r>
+              <a:rPr lang="sk-SK" dirty="0"/>
+              <a:t>.</a:t>
+            </a:r>
+          </a:p>
+        </p:txBody>
+      </p:sp>
+      <p:sp>
+        <p:nvSpPr>
+          <p:cNvPr id="4" name="Zástupný objekt pre číslo snímky 3"/>
+          <p:cNvSpPr>
+            <a:spLocks noGrp="1"/>
+          </p:cNvSpPr>
+          <p:nvPr>
+            <p:ph type="sldNum" sz="quarter" idx="5"/>
+          </p:nvPr>
+        </p:nvSpPr>
+        <p:spPr/>
+        <p:txBody>
+          <a:bodyPr/>
+          <a:lstStyle/>
+          <a:p>
+            <a:fld id="{720C6227-A214-42BB-84EB-9C7415895DDE}" type="slidenum">
+              <a:rPr lang="sk-SK" smtClean="0"/>
+              <a:t>6</a:t>
+            </a:fld>
+            <a:endParaRPr lang="sk-SK"/>
+          </a:p>
+        </p:txBody>
+      </p:sp>
+    </p:spTree>
+    <p:extLst>
+      <p:ext uri="{BB962C8B-B14F-4D97-AF65-F5344CB8AC3E}">
+        <p14:creationId xmlns:p14="http://schemas.microsoft.com/office/powerpoint/2010/main" val="3287932988"/>
+      </p:ext>
+    </p:extLst>
+  </p:cSld>
+  <p:clrMapOvr>
+    <a:masterClrMapping/>
+  </p:clrMapOvr>
+</p:notes>
+</file>
+
+<file path=ppt/notesSlides/notesSlide7.xml><?xml version="1.0" encoding="utf-8"?>
+<p:notes xmlns:a="http://schemas.openxmlformats.org/drawingml/2006/main" xmlns:r="http://schemas.openxmlformats.org/officeDocument/2006/relationships" xmlns:p="http://schemas.openxmlformats.org/presentationml/2006/main">
+  <p:cSld>
+    <p:spTree>
+      <p:nvGrpSpPr>
+        <p:cNvPr id="1" name=""/>
+        <p:cNvGrpSpPr/>
+        <p:nvPr/>
+      </p:nvGrpSpPr>
+      <p:grpSpPr>
+        <a:xfrm>
+          <a:off x="0" y="0"/>
+          <a:ext cx="0" cy="0"/>
+          <a:chOff x="0" y="0"/>
+          <a:chExt cx="0" cy="0"/>
+        </a:xfrm>
+      </p:grpSpPr>
+      <p:sp>
+        <p:nvSpPr>
+          <p:cNvPr id="2" name="Zástupný objekt pre obrázok snímky 1"/>
+          <p:cNvSpPr>
+            <a:spLocks noGrp="1" noRot="1" noChangeAspect="1"/>
+          </p:cNvSpPr>
+          <p:nvPr>
+            <p:ph type="sldImg"/>
+          </p:nvPr>
+        </p:nvSpPr>
+        <p:spPr/>
+      </p:sp>
+      <p:sp>
+        <p:nvSpPr>
+          <p:cNvPr id="3" name="Zástupný objekt pre poznámky 2"/>
+          <p:cNvSpPr>
+            <a:spLocks noGrp="1"/>
+          </p:cNvSpPr>
+          <p:nvPr>
+            <p:ph type="body" idx="1"/>
+          </p:nvPr>
+        </p:nvSpPr>
+        <p:spPr/>
+        <p:txBody>
+          <a:bodyPr/>
+          <a:lstStyle/>
+          <a:p>
+            <a:r>
+              <a:rPr lang="sk-SK" dirty="0"/>
+              <a:t>Popísať jednotlivé ekonometrické modely a vybrané modely strojového učenia. Vysvetliť voľbu </a:t>
+            </a:r>
+            <a:r>
+              <a:rPr lang="sk-SK" dirty="0" err="1"/>
+              <a:t>rolling-window</a:t>
+            </a:r>
+            <a:r>
+              <a:rPr lang="sk-SK" dirty="0"/>
+              <a:t> prístupu.</a:t>
+            </a:r>
+          </a:p>
+          <a:p>
+            <a:endParaRPr lang="sk-SK" dirty="0"/>
+          </a:p>
+          <a:p>
+            <a:r>
+              <a:rPr lang="sk-SK" dirty="0"/>
+              <a:t>Modely:</a:t>
+            </a:r>
+          </a:p>
+          <a:p>
+            <a:r>
+              <a:rPr lang="sk-SK" dirty="0"/>
+              <a:t>GARCH modeluje očakávanú volatilitu v čase na základe minulých šokov a hodnôt volatility. V podstate modeluje na základe „pamäti“ volatility.</a:t>
+            </a:r>
+          </a:p>
+          <a:p>
+            <a:r>
+              <a:rPr lang="sk-SK" dirty="0"/>
+              <a:t>GJR-GARCH je rozšírenie GARCH modelu, ktorý dokáže zachytiť asymetriu volatility. To je zásadné pretože vo všeobecnosti platí, že vysoká volatilita ovplyvňuje trh viac ako nízka volatilita.</a:t>
+            </a:r>
+          </a:p>
+          <a:p>
+            <a:r>
+              <a:rPr lang="sk-SK" dirty="0"/>
+              <a:t>HAR model je </a:t>
+            </a:r>
+            <a:r>
+              <a:rPr lang="sk-SK" dirty="0" err="1"/>
+              <a:t>autoregresívny</a:t>
+            </a:r>
+            <a:r>
+              <a:rPr lang="sk-SK" dirty="0"/>
+              <a:t> model volatility, ktorý pracuje s predikciou realizovanej volatility. Je ľahko interpretovateľný.</a:t>
+            </a:r>
+          </a:p>
+          <a:p>
+            <a:r>
+              <a:rPr lang="sk-SK" dirty="0" err="1"/>
+              <a:t>XGBoost</a:t>
+            </a:r>
+            <a:r>
+              <a:rPr lang="sk-SK" dirty="0"/>
+              <a:t> alebo </a:t>
+            </a:r>
+            <a:r>
+              <a:rPr lang="sk-SK" dirty="0" err="1"/>
+              <a:t>Extreme</a:t>
+            </a:r>
+            <a:r>
+              <a:rPr lang="sk-SK" dirty="0"/>
+              <a:t> Gradient </a:t>
+            </a:r>
+            <a:r>
+              <a:rPr lang="sk-SK" dirty="0" err="1"/>
+              <a:t>Boosting</a:t>
+            </a:r>
+            <a:r>
+              <a:rPr lang="sk-SK" dirty="0"/>
+              <a:t> je model strojového učenia založený na rozhodovacích stromoch, ktorý dokáže zachytiť nelineárne vzťahy medzi premennými. Dokáže určiť dôležitosť jednotlivých premenných.</a:t>
+            </a:r>
+          </a:p>
+          <a:p>
+            <a:r>
+              <a:rPr lang="sk-SK" dirty="0"/>
+              <a:t>LSTM je </a:t>
+            </a:r>
+            <a:r>
+              <a:rPr lang="sk-SK" dirty="0" err="1"/>
+              <a:t>rekurentná</a:t>
+            </a:r>
+            <a:r>
+              <a:rPr lang="sk-SK" dirty="0"/>
+              <a:t> neurónová sieť založená na sekvenčné dáta. Na základe predchádzajúcich dát volatility dokáže predikovať budúcu volatilitu.</a:t>
+            </a:r>
+          </a:p>
+          <a:p>
+            <a:endParaRPr lang="sk-SK" dirty="0"/>
+          </a:p>
+          <a:p>
+            <a:r>
+              <a:rPr lang="sk-SK" dirty="0"/>
+              <a:t>Spomenúť:</a:t>
+            </a:r>
+          </a:p>
+          <a:p>
+            <a:r>
+              <a:rPr lang="sk-SK" sz="1200" kern="1200" dirty="0">
+                <a:solidFill>
+                  <a:schemeClr val="tx1"/>
+                </a:solidFill>
+                <a:effectLst/>
+                <a:latin typeface="+mn-lt"/>
+                <a:ea typeface="+mn-ea"/>
+                <a:cs typeface="+mn-cs"/>
+              </a:rPr>
+              <a:t>„Dáta budú transformované na logaritmické výnosy a následne budú analyzované ich vlastnosti ako </a:t>
+            </a:r>
+            <a:r>
+              <a:rPr lang="sk-SK" sz="1200" kern="1200" dirty="0" err="1">
+                <a:solidFill>
+                  <a:schemeClr val="tx1"/>
+                </a:solidFill>
+                <a:effectLst/>
+                <a:latin typeface="+mn-lt"/>
+                <a:ea typeface="+mn-ea"/>
+                <a:cs typeface="+mn-cs"/>
+              </a:rPr>
+              <a:t>stacionarita</a:t>
+            </a:r>
+            <a:r>
+              <a:rPr lang="sk-SK" sz="1200" kern="1200" dirty="0">
+                <a:solidFill>
+                  <a:schemeClr val="tx1"/>
+                </a:solidFill>
+                <a:effectLst/>
+                <a:latin typeface="+mn-lt"/>
+                <a:ea typeface="+mn-ea"/>
+                <a:cs typeface="+mn-cs"/>
+              </a:rPr>
+              <a:t>, </a:t>
+            </a:r>
+            <a:r>
+              <a:rPr lang="sk-SK" sz="1200" kern="1200" dirty="0" err="1">
+                <a:solidFill>
+                  <a:schemeClr val="tx1"/>
+                </a:solidFill>
+                <a:effectLst/>
+                <a:latin typeface="+mn-lt"/>
+                <a:ea typeface="+mn-ea"/>
+                <a:cs typeface="+mn-cs"/>
+              </a:rPr>
+              <a:t>autokorelácia</a:t>
+            </a:r>
+            <a:r>
+              <a:rPr lang="sk-SK" sz="1200" kern="1200" dirty="0">
+                <a:solidFill>
+                  <a:schemeClr val="tx1"/>
+                </a:solidFill>
+                <a:effectLst/>
+                <a:latin typeface="+mn-lt"/>
+                <a:ea typeface="+mn-ea"/>
+                <a:cs typeface="+mn-cs"/>
+              </a:rPr>
+              <a:t> a </a:t>
+            </a:r>
+            <a:r>
+              <a:rPr lang="sk-SK" sz="1200" kern="1200" dirty="0" err="1">
+                <a:solidFill>
+                  <a:schemeClr val="tx1"/>
+                </a:solidFill>
+                <a:effectLst/>
+                <a:latin typeface="+mn-lt"/>
+                <a:ea typeface="+mn-ea"/>
+                <a:cs typeface="+mn-cs"/>
+              </a:rPr>
+              <a:t>heteroskedasticita</a:t>
+            </a:r>
+            <a:r>
+              <a:rPr lang="sk-SK" sz="1200" kern="1200" dirty="0">
+                <a:solidFill>
+                  <a:schemeClr val="tx1"/>
+                </a:solidFill>
+                <a:effectLst/>
+                <a:latin typeface="+mn-lt"/>
+                <a:ea typeface="+mn-ea"/>
+                <a:cs typeface="+mn-cs"/>
+              </a:rPr>
+              <a:t>.</a:t>
+            </a:r>
+          </a:p>
+          <a:p>
+            <a:r>
+              <a:rPr lang="sk-SK" sz="1200" kern="1200" dirty="0">
+                <a:solidFill>
+                  <a:schemeClr val="tx1"/>
+                </a:solidFill>
+                <a:effectLst/>
+                <a:latin typeface="+mn-lt"/>
+                <a:ea typeface="+mn-ea"/>
+                <a:cs typeface="+mn-cs"/>
+              </a:rPr>
+              <a:t>Takto predspracované dáta budú ďalej vhodné ako vstup pre ekonometrické modely a metódy umelej inteligencie.“</a:t>
+            </a:r>
+            <a:r>
+              <a:rPr lang="en-US" sz="1200" kern="1200" dirty="0">
+                <a:solidFill>
+                  <a:schemeClr val="tx1"/>
+                </a:solidFill>
+                <a:effectLst/>
+                <a:latin typeface="+mn-lt"/>
+                <a:ea typeface="+mn-ea"/>
+                <a:cs typeface="+mn-cs"/>
+              </a:rPr>
+              <a:t> </a:t>
+            </a:r>
+            <a:r>
+              <a:rPr lang="en-US" sz="1200" kern="1200" dirty="0" err="1">
+                <a:solidFill>
+                  <a:schemeClr val="tx1"/>
+                </a:solidFill>
+                <a:effectLst/>
+                <a:latin typeface="+mn-lt"/>
+                <a:ea typeface="+mn-ea"/>
+                <a:cs typeface="+mn-cs"/>
+              </a:rPr>
+              <a:t>Logaritmick</a:t>
+            </a:r>
+            <a:r>
+              <a:rPr lang="sk-SK" sz="1200" kern="1200" dirty="0">
+                <a:solidFill>
+                  <a:schemeClr val="tx1"/>
+                </a:solidFill>
+                <a:effectLst/>
+                <a:latin typeface="+mn-lt"/>
+                <a:ea typeface="+mn-ea"/>
+                <a:cs typeface="+mn-cs"/>
+              </a:rPr>
+              <a:t>é výnosy sú: </a:t>
+            </a:r>
+            <a:r>
+              <a:rPr lang="sk-SK" sz="1200" kern="1200" dirty="0" err="1">
+                <a:solidFill>
+                  <a:schemeClr val="tx1"/>
+                </a:solidFill>
+                <a:effectLst/>
+                <a:latin typeface="+mn-lt"/>
+                <a:ea typeface="+mn-ea"/>
+                <a:cs typeface="+mn-cs"/>
+              </a:rPr>
+              <a:t>ln</a:t>
+            </a:r>
+            <a:r>
+              <a:rPr lang="en-US" sz="1200" kern="1200" dirty="0">
+                <a:solidFill>
+                  <a:schemeClr val="tx1"/>
+                </a:solidFill>
+                <a:effectLst/>
+                <a:latin typeface="+mn-lt"/>
+                <a:ea typeface="+mn-ea"/>
+                <a:cs typeface="+mn-cs"/>
+              </a:rPr>
+              <a:t>(</a:t>
+            </a:r>
+            <a:r>
+              <a:rPr lang="en-US" sz="1200" kern="1200" dirty="0" err="1">
+                <a:solidFill>
+                  <a:schemeClr val="tx1"/>
+                </a:solidFill>
+                <a:effectLst/>
+                <a:latin typeface="+mn-lt"/>
+                <a:ea typeface="+mn-ea"/>
+                <a:cs typeface="+mn-cs"/>
+              </a:rPr>
+              <a:t>CLOSEt</a:t>
+            </a:r>
+            <a:r>
+              <a:rPr lang="en-US" sz="1200" kern="1200" dirty="0">
+                <a:solidFill>
+                  <a:schemeClr val="tx1"/>
+                </a:solidFill>
+                <a:effectLst/>
+                <a:latin typeface="+mn-lt"/>
+                <a:ea typeface="+mn-ea"/>
+                <a:cs typeface="+mn-cs"/>
+              </a:rPr>
+              <a:t>) - ln(CLOSEt-1)</a:t>
+            </a:r>
+            <a:endParaRPr lang="sk-SK" dirty="0"/>
+          </a:p>
+        </p:txBody>
+      </p:sp>
+      <p:sp>
+        <p:nvSpPr>
+          <p:cNvPr id="4" name="Zástupný objekt pre číslo snímky 3"/>
+          <p:cNvSpPr>
+            <a:spLocks noGrp="1"/>
+          </p:cNvSpPr>
+          <p:nvPr>
+            <p:ph type="sldNum" sz="quarter" idx="5"/>
+          </p:nvPr>
+        </p:nvSpPr>
+        <p:spPr/>
+        <p:txBody>
+          <a:bodyPr/>
+          <a:lstStyle/>
+          <a:p>
+            <a:fld id="{720C6227-A214-42BB-84EB-9C7415895DDE}" type="slidenum">
+              <a:rPr lang="sk-SK" smtClean="0"/>
+              <a:t>7</a:t>
+            </a:fld>
+            <a:endParaRPr lang="sk-SK"/>
+          </a:p>
+        </p:txBody>
+      </p:sp>
+    </p:spTree>
+    <p:extLst>
+      <p:ext uri="{BB962C8B-B14F-4D97-AF65-F5344CB8AC3E}">
+        <p14:creationId xmlns:p14="http://schemas.microsoft.com/office/powerpoint/2010/main" val="1744240258"/>
+      </p:ext>
+    </p:extLst>
+  </p:cSld>
+  <p:clrMapOvr>
+    <a:masterClrMapping/>
+  </p:clrMapOvr>
+</p:notes>
+</file>
+
+<file path=ppt/notesSlides/notesSlide8.xml><?xml version="1.0" encoding="utf-8"?>
+<p:notes xmlns:a="http://schemas.openxmlformats.org/drawingml/2006/main" xmlns:r="http://schemas.openxmlformats.org/officeDocument/2006/relationships" xmlns:p="http://schemas.openxmlformats.org/presentationml/2006/main">
+  <p:cSld>
+    <p:spTree>
+      <p:nvGrpSpPr>
+        <p:cNvPr id="1" name=""/>
+        <p:cNvGrpSpPr/>
+        <p:nvPr/>
+      </p:nvGrpSpPr>
+      <p:grpSpPr>
+        <a:xfrm>
+          <a:off x="0" y="0"/>
+          <a:ext cx="0" cy="0"/>
+          <a:chOff x="0" y="0"/>
+          <a:chExt cx="0" cy="0"/>
+        </a:xfrm>
+      </p:grpSpPr>
+      <p:sp>
+        <p:nvSpPr>
+          <p:cNvPr id="2" name="Zástupný objekt pre obrázok snímky 1"/>
+          <p:cNvSpPr>
+            <a:spLocks noGrp="1" noRot="1" noChangeAspect="1"/>
+          </p:cNvSpPr>
+          <p:nvPr>
+            <p:ph type="sldImg"/>
+          </p:nvPr>
+        </p:nvSpPr>
+        <p:spPr/>
+      </p:sp>
+      <p:sp>
+        <p:nvSpPr>
+          <p:cNvPr id="3" name="Zástupný objekt pre poznámky 2"/>
+          <p:cNvSpPr>
+            <a:spLocks noGrp="1"/>
+          </p:cNvSpPr>
+          <p:nvPr>
+            <p:ph type="body" idx="1"/>
+          </p:nvPr>
+        </p:nvSpPr>
+        <p:spPr/>
+        <p:txBody>
+          <a:bodyPr/>
+          <a:lstStyle/>
+          <a:p>
+            <a:r>
+              <a:rPr lang="en-US" dirty="0"/>
+              <a:t>Vy</a:t>
+            </a:r>
+            <a:r>
+              <a:rPr lang="sk-SK" dirty="0"/>
+              <a:t>svetliť metriky a spôsob vyhodnotenia.</a:t>
+            </a:r>
+          </a:p>
+          <a:p>
+            <a:endParaRPr lang="sk-SK" dirty="0"/>
+          </a:p>
+          <a:p>
+            <a:r>
+              <a:rPr lang="sk-SK" dirty="0"/>
+              <a:t>Metriky:</a:t>
+            </a:r>
+          </a:p>
+          <a:p>
+            <a:r>
+              <a:rPr lang="sk-SK" dirty="0"/>
+              <a:t>RMSE alebo </a:t>
+            </a:r>
+            <a:r>
+              <a:rPr lang="sk-SK" dirty="0" err="1"/>
+              <a:t>Root</a:t>
+            </a:r>
+            <a:r>
+              <a:rPr lang="sk-SK" dirty="0"/>
+              <a:t> </a:t>
+            </a:r>
+            <a:r>
+              <a:rPr lang="sk-SK" dirty="0" err="1"/>
+              <a:t>Mean</a:t>
+            </a:r>
+            <a:r>
+              <a:rPr lang="sk-SK" dirty="0"/>
+              <a:t> </a:t>
+            </a:r>
+            <a:r>
+              <a:rPr lang="sk-SK" dirty="0" err="1"/>
+              <a:t>Squared</a:t>
+            </a:r>
+            <a:r>
+              <a:rPr lang="sk-SK" dirty="0"/>
+              <a:t> </a:t>
+            </a:r>
+            <a:r>
+              <a:rPr lang="sk-SK" dirty="0" err="1"/>
+              <a:t>Error</a:t>
+            </a:r>
+            <a:r>
+              <a:rPr lang="sk-SK" dirty="0"/>
+              <a:t> je odmocnina priemernej štvorcovej chyby. Meria priemernú chybu modelu pričom veľké chyby trestá silnejšie.</a:t>
+            </a:r>
+          </a:p>
+          <a:p>
+            <a:r>
+              <a:rPr lang="sk-SK" dirty="0"/>
+              <a:t>QLIKE sleduje pomer medzi skutočnou a predikovanou </a:t>
+            </a:r>
+            <a:r>
+              <a:rPr lang="sk-SK" dirty="0" err="1"/>
+              <a:t>varianciou</a:t>
+            </a:r>
+            <a:r>
+              <a:rPr lang="sk-SK" dirty="0"/>
+              <a:t>, pričom rovnako ako RMSE výrazne trestá veľké odchýlky.</a:t>
+            </a:r>
+          </a:p>
+          <a:p>
+            <a:endParaRPr lang="sk-SK" dirty="0"/>
+          </a:p>
+          <a:p>
+            <a:r>
+              <a:rPr lang="sk-SK" dirty="0"/>
+              <a:t>Porovnanie správania volatility:</a:t>
+            </a:r>
+          </a:p>
+          <a:p>
+            <a:r>
+              <a:rPr lang="sk-SK" dirty="0"/>
+              <a:t>- priemerná volatilita,</a:t>
+            </a:r>
+          </a:p>
+          <a:p>
+            <a:r>
+              <a:rPr lang="sk-SK" dirty="0"/>
+              <a:t>- maximálna volatilita,</a:t>
+            </a:r>
+          </a:p>
+          <a:p>
+            <a:r>
+              <a:rPr lang="sk-SK" dirty="0"/>
+              <a:t>- </a:t>
+            </a:r>
+            <a:r>
+              <a:rPr lang="sk-SK" dirty="0" err="1"/>
+              <a:t>perzistencia</a:t>
+            </a:r>
+            <a:r>
+              <a:rPr lang="sk-SK" dirty="0"/>
+              <a:t> volatility,</a:t>
+            </a:r>
+          </a:p>
+          <a:p>
+            <a:r>
+              <a:rPr lang="sk-SK" dirty="0"/>
+              <a:t>- presnosť modelov,</a:t>
+            </a:r>
+          </a:p>
+          <a:p>
+            <a:pPr marL="0" indent="0">
+              <a:buFontTx/>
+              <a:buNone/>
+            </a:pPr>
+            <a:r>
+              <a:rPr lang="sk-SK" dirty="0"/>
+              <a:t>- identifikácia najdôležitejších vstupných premenných</a:t>
+            </a:r>
+          </a:p>
+          <a:p>
+            <a:pPr marL="0" indent="0">
+              <a:buFontTx/>
+              <a:buNone/>
+            </a:pPr>
+            <a:endParaRPr lang="sk-SK" dirty="0"/>
+          </a:p>
+          <a:p>
+            <a:pPr marL="0" indent="0">
+              <a:buFontTx/>
+              <a:buNone/>
+            </a:pPr>
+            <a:r>
+              <a:rPr lang="sk-SK" dirty="0"/>
+              <a:t>Identifikácia vplyvu geopolitických šokov na volatilitu bude robená porovnaním spomínaných časových období, s dôrazom na pandémiu COVID-19.</a:t>
+            </a:r>
+          </a:p>
+          <a:p>
+            <a:pPr marL="0" indent="0">
+              <a:buFontTx/>
+              <a:buNone/>
+            </a:pPr>
+            <a:r>
+              <a:rPr lang="sk-SK" dirty="0"/>
+              <a:t>Identifikácia faktorov vplývajúcich na volatilitu trhov bude robená cez dostupné vyhlásenia, vyjadrenia politických predstaviteľov, alebo stanoviská konkrétnych firiem.</a:t>
+            </a:r>
+          </a:p>
+          <a:p>
+            <a:pPr marL="0" indent="0">
+              <a:buFontTx/>
+              <a:buNone/>
+            </a:pPr>
+            <a:endParaRPr lang="sk-SK" dirty="0"/>
+          </a:p>
+          <a:p>
+            <a:pPr marL="0" indent="0">
+              <a:buFontTx/>
+              <a:buNone/>
+            </a:pPr>
+            <a:r>
+              <a:rPr lang="sk-SK" dirty="0"/>
+              <a:t>Výsledkom výskumu bude nielen definovaná metodiky na spracovanie časových radov, ale aj identifikované vzory v časových radoch indexov akcií, faktory vplývajúce na volatilitu trhov, porovnanie ekonometrických modelov a modelov strojového a hlbokého učenia a dôkaz o robustnosti výsledkov naprieč rôznymi zdrojmi dát. </a:t>
+            </a:r>
+          </a:p>
+          <a:p>
+            <a:pPr marL="0" indent="0">
+              <a:buFontTx/>
+              <a:buNone/>
+            </a:pPr>
+            <a:endParaRPr lang="sk-SK" dirty="0"/>
+          </a:p>
+        </p:txBody>
+      </p:sp>
+      <p:sp>
+        <p:nvSpPr>
+          <p:cNvPr id="4" name="Zástupný objekt pre číslo snímky 3"/>
+          <p:cNvSpPr>
+            <a:spLocks noGrp="1"/>
+          </p:cNvSpPr>
+          <p:nvPr>
+            <p:ph type="sldNum" sz="quarter" idx="5"/>
+          </p:nvPr>
+        </p:nvSpPr>
+        <p:spPr/>
+        <p:txBody>
+          <a:bodyPr/>
+          <a:lstStyle/>
+          <a:p>
+            <a:fld id="{720C6227-A214-42BB-84EB-9C7415895DDE}" type="slidenum">
+              <a:rPr lang="sk-SK" smtClean="0"/>
+              <a:t>8</a:t>
+            </a:fld>
+            <a:endParaRPr lang="sk-SK"/>
+          </a:p>
+        </p:txBody>
+      </p:sp>
+    </p:spTree>
+    <p:extLst>
+      <p:ext uri="{BB962C8B-B14F-4D97-AF65-F5344CB8AC3E}">
+        <p14:creationId xmlns:p14="http://schemas.microsoft.com/office/powerpoint/2010/main" val="1225414240"/>
+      </p:ext>
+    </p:extLst>
+  </p:cSld>
+  <p:clrMapOvr>
+    <a:masterClrMapping/>
+  </p:clrMapOvr>
+</p:notes>
+</file>
+
 <file path=ppt/slideLayouts/slideLayout1.xml><?xml version="1.0" encoding="utf-8"?>
 <p:sldLayout xmlns:a="http://schemas.openxmlformats.org/drawingml/2006/main" xmlns:r="http://schemas.openxmlformats.org/officeDocument/2006/relationships" xmlns:p="http://schemas.openxmlformats.org/presentationml/2006/main" type="title" preserve="1">
   <p:cSld name="Úvodná snímka">
@@ -4896,7 +6457,7 @@
           <a:p>
             <a:fld id="{02AC24A9-CCB6-4F8D-B8DB-C2F3692CFA5A}" type="datetimeFigureOut">
               <a:rPr lang="en-US" smtClean="0"/>
-              <a:t>6/20/2026</a:t>
+              <a:t>6/21/2026</a:t>
             </a:fld>
             <a:endParaRPr lang="en-US" dirty="0"/>
           </a:p>
@@ -5267,7 +6828,7 @@
           <a:p>
             <a:fld id="{02AC24A9-CCB6-4F8D-B8DB-C2F3692CFA5A}" type="datetimeFigureOut">
               <a:rPr lang="en-US" smtClean="0"/>
-              <a:t>6/20/2026</a:t>
+              <a:t>6/21/2026</a:t>
             </a:fld>
             <a:endParaRPr lang="en-US" dirty="0"/>
           </a:p>
@@ -5477,7 +7038,7 @@
           <a:p>
             <a:fld id="{02AC24A9-CCB6-4F8D-B8DB-C2F3692CFA5A}" type="datetimeFigureOut">
               <a:rPr lang="en-US" smtClean="0"/>
-              <a:t>6/20/2026</a:t>
+              <a:t>6/21/2026</a:t>
             </a:fld>
             <a:endParaRPr lang="en-US" dirty="0"/>
           </a:p>
@@ -5949,7 +7510,7 @@
           <a:p>
             <a:fld id="{02AC24A9-CCB6-4F8D-B8DB-C2F3692CFA5A}" type="datetimeFigureOut">
               <a:rPr lang="en-US" smtClean="0"/>
-              <a:t>6/20/2026</a:t>
+              <a:t>6/21/2026</a:t>
             </a:fld>
             <a:endParaRPr lang="en-US" dirty="0"/>
           </a:p>
@@ -6404,7 +7965,7 @@
           <a:p>
             <a:fld id="{02AC24A9-CCB6-4F8D-B8DB-C2F3692CFA5A}" type="datetimeFigureOut">
               <a:rPr lang="en-US" smtClean="0"/>
-              <a:t>6/20/2026</a:t>
+              <a:t>6/21/2026</a:t>
             </a:fld>
             <a:endParaRPr lang="en-US" dirty="0"/>
           </a:p>
@@ -6939,7 +8500,7 @@
           <a:p>
             <a:fld id="{02AC24A9-CCB6-4F8D-B8DB-C2F3692CFA5A}" type="datetimeFigureOut">
               <a:rPr lang="en-US" smtClean="0"/>
-              <a:t>6/20/2026</a:t>
+              <a:t>6/21/2026</a:t>
             </a:fld>
             <a:endParaRPr lang="en-US" dirty="0"/>
           </a:p>
@@ -7641,7 +9202,7 @@
           <a:p>
             <a:fld id="{02AC24A9-CCB6-4F8D-B8DB-C2F3692CFA5A}" type="datetimeFigureOut">
               <a:rPr lang="en-US" smtClean="0"/>
-              <a:t>6/20/2026</a:t>
+              <a:t>6/21/2026</a:t>
             </a:fld>
             <a:endParaRPr lang="en-US" dirty="0"/>
           </a:p>
@@ -7971,7 +9532,7 @@
           <a:p>
             <a:fld id="{02AC24A9-CCB6-4F8D-B8DB-C2F3692CFA5A}" type="datetimeFigureOut">
               <a:rPr lang="en-US" smtClean="0"/>
-              <a:t>6/20/2026</a:t>
+              <a:t>6/21/2026</a:t>
             </a:fld>
             <a:endParaRPr lang="en-US" dirty="0"/>
           </a:p>
@@ -8084,7 +9645,7 @@
           <a:p>
             <a:fld id="{02AC24A9-CCB6-4F8D-B8DB-C2F3692CFA5A}" type="datetimeFigureOut">
               <a:rPr lang="en-US" smtClean="0"/>
-              <a:t>6/20/2026</a:t>
+              <a:t>6/21/2026</a:t>
             </a:fld>
             <a:endParaRPr lang="en-US" dirty="0"/>
           </a:p>
@@ -8581,7 +10142,7 @@
           <a:p>
             <a:fld id="{02AC24A9-CCB6-4F8D-B8DB-C2F3692CFA5A}" type="datetimeFigureOut">
               <a:rPr lang="en-US" smtClean="0"/>
-              <a:t>6/20/2026</a:t>
+              <a:t>6/21/2026</a:t>
             </a:fld>
             <a:endParaRPr lang="en-US" dirty="0"/>
           </a:p>
@@ -9060,7 +10621,7 @@
           <a:p>
             <a:fld id="{02AC24A9-CCB6-4F8D-B8DB-C2F3692CFA5A}" type="datetimeFigureOut">
               <a:rPr lang="en-US" smtClean="0"/>
-              <a:t>6/20/2026</a:t>
+              <a:t>6/21/2026</a:t>
             </a:fld>
             <a:endParaRPr lang="en-US" dirty="0"/>
           </a:p>
@@ -9303,7 +10864,7 @@
           <a:p>
             <a:fld id="{02AC24A9-CCB6-4F8D-B8DB-C2F3692CFA5A}" type="datetimeFigureOut">
               <a:rPr lang="en-US" smtClean="0"/>
-              <a:t>6/20/2026</a:t>
+              <a:t>6/21/2026</a:t>
             </a:fld>
             <a:endParaRPr lang="en-US" dirty="0"/>
           </a:p>
@@ -10103,7 +11664,7 @@
           <p:cNvPr id="2" name="Nadpis 1">
             <a:extLst>
               <a:ext uri="{FF2B5EF4-FFF2-40B4-BE49-F238E27FC236}">
-                <a16:creationId xmlns:a16="http://schemas.microsoft.com/office/drawing/2014/main" id="{3969CCF5-1DBC-D64F-A418-E0D3525AF056}"/>
+                <a16:creationId xmlns:a16="http://schemas.microsoft.com/office/drawing/2014/main" id="{FF10AEA6-20C5-7F84-4661-BE5DBE2AC4D7}"/>
               </a:ext>
             </a:extLst>
           </p:cNvPr>
@@ -10129,7 +11690,7 @@
                   </a:outerShdw>
                 </a:effectLst>
               </a:rPr>
-              <a:t>Hypotézy</a:t>
+              <a:t>Očakávané prínosy výskumu</a:t>
             </a:r>
           </a:p>
         </p:txBody>
@@ -10139,7 +11700,7 @@
           <p:cNvPr id="3" name="Zástupný objekt pre obsah 2">
             <a:extLst>
               <a:ext uri="{FF2B5EF4-FFF2-40B4-BE49-F238E27FC236}">
-                <a16:creationId xmlns:a16="http://schemas.microsoft.com/office/drawing/2014/main" id="{D299E122-982E-024E-9B3B-050AE20DA6B9}"/>
+                <a16:creationId xmlns:a16="http://schemas.microsoft.com/office/drawing/2014/main" id="{1E207072-0098-DFCC-2110-537C30EE2679}"/>
               </a:ext>
             </a:extLst>
           </p:cNvPr>
@@ -10152,58 +11713,25 @@
         </p:nvSpPr>
         <p:spPr>
           <a:xfrm>
-            <a:off x="1115568" y="2478024"/>
-            <a:ext cx="10650862" cy="3831336"/>
+            <a:off x="1115568" y="2478023"/>
+            <a:ext cx="10650862" cy="3698489"/>
           </a:xfrm>
         </p:spPr>
         <p:txBody>
           <a:bodyPr>
-            <a:normAutofit lnSpcReduction="10000"/>
+            <a:normAutofit/>
           </a:bodyPr>
           <a:lstStyle/>
           <a:p>
-            <a:r>
-              <a:rPr lang="sk-SK" sz="2000" b="1" dirty="0"/>
-              <a:t>H1: </a:t>
-            </a:r>
-            <a:r>
-              <a:rPr lang="sk-SK" sz="2000" dirty="0"/>
-              <a:t>Obdobie pandémie </a:t>
-            </a:r>
-            <a:r>
-              <a:rPr lang="sk-SK" sz="2000" i="1" dirty="0"/>
-              <a:t>COVID-19</a:t>
-            </a:r>
-            <a:r>
-              <a:rPr lang="sk-SK" sz="2000" dirty="0"/>
-              <a:t> viedlo k štatisticky významnému zvýšeniu volatility vybraných akciových indexov </a:t>
-            </a:r>
-            <a:r>
-              <a:rPr lang="sk-SK" sz="2000" i="1" dirty="0"/>
-              <a:t>USA</a:t>
-            </a:r>
-            <a:r>
-              <a:rPr lang="sk-SK" sz="2000" dirty="0"/>
-              <a:t>, </a:t>
-            </a:r>
-            <a:r>
-              <a:rPr lang="sk-SK" sz="2000" i="1" dirty="0"/>
-              <a:t>Európy</a:t>
-            </a:r>
-            <a:r>
-              <a:rPr lang="sk-SK" sz="2000" dirty="0"/>
-              <a:t> a </a:t>
-            </a:r>
-            <a:r>
-              <a:rPr lang="sk-SK" sz="2000" i="1" dirty="0"/>
-              <a:t>Číny</a:t>
-            </a:r>
-            <a:r>
-              <a:rPr lang="sk-SK" sz="2000" dirty="0"/>
-              <a:t>.</a:t>
-            </a:r>
-          </a:p>
-          <a:p>
+            <a:pPr>
+              <a:buClr>
+                <a:schemeClr val="tx1">
+                  <a:lumMod val="95000"/>
+                  <a:lumOff val="5000"/>
+                </a:schemeClr>
+              </a:buClr>
+              <a:buSzPct val="110000"/>
+            </a:pPr>
             <a:r>
               <a:rPr lang="sk-SK" sz="2000" b="1" dirty="0">
                 <a:effectLst>
@@ -10214,38 +11742,23 @@
                   </a:outerShdw>
                 </a:effectLst>
               </a:rPr>
-              <a:t>H2: </a:t>
+              <a:t>1. </a:t>
             </a:r>
             <a:r>
               <a:rPr lang="sk-SK" sz="2000" dirty="0"/>
-              <a:t>Dynamika volatility sa medzi vybranými trhmi </a:t>
-            </a:r>
-            <a:r>
-              <a:rPr lang="sk-SK" sz="2000" i="1" dirty="0"/>
-              <a:t>USA</a:t>
-            </a:r>
-            <a:r>
-              <a:rPr lang="sk-SK" sz="2000" dirty="0"/>
-              <a:t>, </a:t>
-            </a:r>
-            <a:r>
-              <a:rPr lang="sk-SK" sz="2000" i="1" dirty="0"/>
-              <a:t>Európy</a:t>
-            </a:r>
-            <a:r>
-              <a:rPr lang="sk-SK" sz="2000" dirty="0"/>
-              <a:t> a </a:t>
-            </a:r>
-            <a:r>
-              <a:rPr lang="sk-SK" sz="2000" i="1" dirty="0"/>
-              <a:t>Číny</a:t>
-            </a:r>
-            <a:r>
-              <a:rPr lang="sk-SK" sz="2000" dirty="0"/>
-              <a:t> štatisticky významne líši.</a:t>
-            </a:r>
-          </a:p>
-          <a:p>
+              <a:t>Empirické porovnanie modelov strojového učenia s ekonometrickými riešeniami,</a:t>
+            </a:r>
+          </a:p>
+          <a:p>
+            <a:pPr>
+              <a:buClr>
+                <a:schemeClr val="tx1">
+                  <a:lumMod val="95000"/>
+                  <a:lumOff val="5000"/>
+                </a:schemeClr>
+              </a:buClr>
+              <a:buSzPct val="110000"/>
+            </a:pPr>
             <a:r>
               <a:rPr lang="sk-SK" sz="2000" b="1" dirty="0">
                 <a:effectLst>
@@ -10256,14 +11769,23 @@
                   </a:outerShdw>
                 </a:effectLst>
               </a:rPr>
-              <a:t>H3: </a:t>
+              <a:t>2. </a:t>
             </a:r>
             <a:r>
               <a:rPr lang="sk-SK" sz="2000" dirty="0"/>
-              <a:t>Asymetrické modely volatility dosahujú lepšiu výkonnosť počas krízových období ako symetrické modely volatility.</a:t>
-            </a:r>
-          </a:p>
-          <a:p>
+              <a:t>Praktické poznatky o správaní akciových trhov počas období so zvýšeným rizikom, </a:t>
+            </a:r>
+          </a:p>
+          <a:p>
+            <a:pPr>
+              <a:buClr>
+                <a:schemeClr val="tx1">
+                  <a:lumMod val="95000"/>
+                  <a:lumOff val="5000"/>
+                </a:schemeClr>
+              </a:buClr>
+              <a:buSzPct val="110000"/>
+            </a:pPr>
             <a:r>
               <a:rPr lang="sk-SK" sz="2000" b="1" dirty="0">
                 <a:effectLst>
@@ -10274,14 +11796,47 @@
                   </a:outerShdw>
                 </a:effectLst>
               </a:rPr>
-              <a:t>H4: </a:t>
+              <a:t>3. </a:t>
             </a:r>
             <a:r>
               <a:rPr lang="sk-SK" sz="2000" dirty="0"/>
-              <a:t>Metódy strojového a hlbokého učenia nemajú štatisticky významne vyššiu predikčnú výkonnosť ako vybrané ekonometrické modely volatility.</a:t>
-            </a:r>
-          </a:p>
-          <a:p>
+              <a:t>Komparatívna analýza volatility akciových trhov </a:t>
+            </a:r>
+            <a:r>
+              <a:rPr lang="sk-SK" sz="2000" i="1" dirty="0"/>
+              <a:t>USA</a:t>
+            </a:r>
+            <a:r>
+              <a:rPr lang="sk-SK" sz="2000" dirty="0"/>
+              <a:t>, </a:t>
+            </a:r>
+            <a:r>
+              <a:rPr lang="sk-SK" sz="2000" i="1" dirty="0"/>
+              <a:t>Európy</a:t>
+            </a:r>
+            <a:r>
+              <a:rPr lang="sk-SK" sz="2000" dirty="0"/>
+              <a:t> a </a:t>
+            </a:r>
+            <a:r>
+              <a:rPr lang="sk-SK" sz="2000" i="1" dirty="0"/>
+              <a:t>Číny</a:t>
+            </a:r>
+            <a:r>
+              <a:rPr lang="sk-SK" sz="2000" dirty="0"/>
+              <a:t>,</a:t>
+            </a:r>
+          </a:p>
+          <a:p>
+            <a:pPr>
+              <a:buClr>
+                <a:schemeClr val="tx1">
+                  <a:lumMod val="95000"/>
+                  <a:lumOff val="5000"/>
+                </a:schemeClr>
+              </a:buClr>
+              <a:buSzPct val="110000"/>
+            </a:pPr>
             <a:r>
               <a:rPr lang="sk-SK" sz="2000" b="1" dirty="0">
                 <a:effectLst>
@@ -10292,11 +11847,65 @@
                   </a:outerShdw>
                 </a:effectLst>
               </a:rPr>
-              <a:t>H5: </a:t>
+              <a:t>4. </a:t>
             </a:r>
             <a:r>
               <a:rPr lang="sk-SK" sz="2000" dirty="0"/>
-              <a:t>Identifikované vzory volatility akciových trhov sa pri použití porovnateľných zdrojov dát štatisticky významne nemenia.</a:t>
+              <a:t>Identifikácia faktorov, ktoré vplývajú na dynamiku volatility,</a:t>
+            </a:r>
+          </a:p>
+          <a:p>
+            <a:pPr>
+              <a:buClr>
+                <a:schemeClr val="tx1">
+                  <a:lumMod val="95000"/>
+                  <a:lumOff val="5000"/>
+                </a:schemeClr>
+              </a:buClr>
+              <a:buSzPct val="110000"/>
+            </a:pPr>
+            <a:r>
+              <a:rPr lang="sk-SK" sz="2000" b="1" dirty="0">
+                <a:effectLst>
+                  <a:outerShdw blurRad="38100" dist="38100" dir="2700000" algn="tl">
+                    <a:srgbClr val="000000">
+                      <a:alpha val="43137"/>
+                    </a:srgbClr>
+                  </a:outerShdw>
+                </a:effectLst>
+              </a:rPr>
+              <a:t>5. </a:t>
+            </a:r>
+            <a:r>
+              <a:rPr lang="sk-SK" sz="2000" dirty="0"/>
+              <a:t>Definícia metodiky pre identifikáciu vzorov v časových radoch akciových trhov s dôrazom na metódy umelej inteligencie,</a:t>
+            </a:r>
+          </a:p>
+          <a:p>
+            <a:pPr>
+              <a:buClr>
+                <a:schemeClr val="tx1">
+                  <a:lumMod val="95000"/>
+                  <a:lumOff val="5000"/>
+                </a:schemeClr>
+              </a:buClr>
+              <a:buSzPct val="110000"/>
+            </a:pPr>
+            <a:r>
+              <a:rPr lang="sk-SK" sz="2000" b="1" dirty="0">
+                <a:effectLst>
+                  <a:outerShdw blurRad="38100" dist="38100" dir="2700000" algn="tl">
+                    <a:srgbClr val="000000">
+                      <a:alpha val="43137"/>
+                    </a:srgbClr>
+                  </a:outerShdw>
+                </a:effectLst>
+              </a:rPr>
+              <a:t>6. </a:t>
+            </a:r>
+            <a:r>
+              <a:rPr lang="sk-SK" sz="2000" dirty="0"/>
+              <a:t>Poznatky o robustnosti definovanej metodiky vzhľadom na zdroj dát akciových indexov.</a:t>
             </a:r>
           </a:p>
         </p:txBody>
@@ -10304,7 +11913,7 @@
     </p:spTree>
     <p:extLst>
       <p:ext uri="{BB962C8B-B14F-4D97-AF65-F5344CB8AC3E}">
-        <p14:creationId xmlns:p14="http://schemas.microsoft.com/office/powerpoint/2010/main" val="1087255654"/>
+        <p14:creationId xmlns:p14="http://schemas.microsoft.com/office/powerpoint/2010/main" val="2170357634"/>
       </p:ext>
     </p:extLst>
   </p:cSld>
@@ -10336,7 +11945,7 @@
           <p:cNvPr id="2" name="Nadpis 1">
             <a:extLst>
               <a:ext uri="{FF2B5EF4-FFF2-40B4-BE49-F238E27FC236}">
-                <a16:creationId xmlns:a16="http://schemas.microsoft.com/office/drawing/2014/main" id="{FF10AEA6-20C5-7F84-4661-BE5DBE2AC4D7}"/>
+                <a16:creationId xmlns:a16="http://schemas.microsoft.com/office/drawing/2014/main" id="{3969CCF5-1DBC-D64F-A418-E0D3525AF056}"/>
               </a:ext>
             </a:extLst>
           </p:cNvPr>
@@ -10362,7 +11971,7 @@
                   </a:outerShdw>
                 </a:effectLst>
               </a:rPr>
-              <a:t>Očakávané prínosy výskumu</a:t>
+              <a:t>Hypotézy</a:t>
             </a:r>
           </a:p>
         </p:txBody>
@@ -10372,7 +11981,7 @@
           <p:cNvPr id="3" name="Zástupný objekt pre obsah 2">
             <a:extLst>
               <a:ext uri="{FF2B5EF4-FFF2-40B4-BE49-F238E27FC236}">
-                <a16:creationId xmlns:a16="http://schemas.microsoft.com/office/drawing/2014/main" id="{1E207072-0098-DFCC-2110-537C30EE2679}"/>
+                <a16:creationId xmlns:a16="http://schemas.microsoft.com/office/drawing/2014/main" id="{D299E122-982E-024E-9B3B-050AE20DA6B9}"/>
               </a:ext>
             </a:extLst>
           </p:cNvPr>
@@ -10385,25 +11994,58 @@
         </p:nvSpPr>
         <p:spPr>
           <a:xfrm>
-            <a:off x="1115568" y="2478023"/>
-            <a:ext cx="10650862" cy="3698489"/>
+            <a:off x="1115568" y="2478024"/>
+            <a:ext cx="10650862" cy="3831336"/>
           </a:xfrm>
         </p:spPr>
         <p:txBody>
           <a:bodyPr>
-            <a:normAutofit/>
+            <a:normAutofit lnSpcReduction="10000"/>
           </a:bodyPr>
           <a:lstStyle/>
           <a:p>
-            <a:pPr>
-              <a:buClr>
-                <a:schemeClr val="tx1">
-                  <a:lumMod val="95000"/>
-                  <a:lumOff val="5000"/>
-                </a:schemeClr>
-              </a:buClr>
-              <a:buSzPct val="110000"/>
-            </a:pPr>
+            <a:r>
+              <a:rPr lang="sk-SK" sz="2000" b="1" dirty="0"/>
+              <a:t>H1: </a:t>
+            </a:r>
+            <a:r>
+              <a:rPr lang="sk-SK" sz="2000" dirty="0"/>
+              <a:t>Obdobie pandémie </a:t>
+            </a:r>
+            <a:r>
+              <a:rPr lang="sk-SK" sz="2000" i="1" dirty="0"/>
+              <a:t>COVID-19</a:t>
+            </a:r>
+            <a:r>
+              <a:rPr lang="sk-SK" sz="2000" dirty="0"/>
+              <a:t> viedlo k štatisticky významnému zvýšeniu volatility vybraných akciových indexov </a:t>
+            </a:r>
+            <a:r>
+              <a:rPr lang="sk-SK" sz="2000" i="1" dirty="0"/>
+              <a:t>USA</a:t>
+            </a:r>
+            <a:r>
+              <a:rPr lang="sk-SK" sz="2000" dirty="0"/>
+              <a:t>, </a:t>
+            </a:r>
+            <a:r>
+              <a:rPr lang="sk-SK" sz="2000" i="1" dirty="0"/>
+              <a:t>Európy</a:t>
+            </a:r>
+            <a:r>
+              <a:rPr lang="sk-SK" sz="2000" dirty="0"/>
+              <a:t> a </a:t>
+            </a:r>
+            <a:r>
+              <a:rPr lang="sk-SK" sz="2000" i="1" dirty="0"/>
+              <a:t>Číny</a:t>
+            </a:r>
+            <a:r>
+              <a:rPr lang="sk-SK" sz="2000" dirty="0"/>
+              <a:t>.</a:t>
+            </a:r>
+          </a:p>
+          <a:p>
             <a:r>
               <a:rPr lang="sk-SK" sz="2000" b="1" dirty="0">
                 <a:effectLst>
@@ -10414,23 +12056,38 @@
                   </a:outerShdw>
                 </a:effectLst>
               </a:rPr>
-              <a:t>1. </a:t>
+              <a:t>H2: </a:t>
             </a:r>
             <a:r>
               <a:rPr lang="sk-SK" sz="2000" dirty="0"/>
-              <a:t>Empirické porovnanie modelov strojového učenia s ekonometrickými riešeniami,</a:t>
-            </a:r>
-          </a:p>
-          <a:p>
-            <a:pPr>
-              <a:buClr>
-                <a:schemeClr val="tx1">
-                  <a:lumMod val="95000"/>
-                  <a:lumOff val="5000"/>
-                </a:schemeClr>
-              </a:buClr>
-              <a:buSzPct val="110000"/>
-            </a:pPr>
+              <a:t>Dynamika volatility sa medzi vybranými trhmi </a:t>
+            </a:r>
+            <a:r>
+              <a:rPr lang="sk-SK" sz="2000" i="1" dirty="0"/>
+              <a:t>USA</a:t>
+            </a:r>
+            <a:r>
+              <a:rPr lang="sk-SK" sz="2000" dirty="0"/>
+              <a:t>, </a:t>
+            </a:r>
+            <a:r>
+              <a:rPr lang="sk-SK" sz="2000" i="1" dirty="0"/>
+              <a:t>Európy</a:t>
+            </a:r>
+            <a:r>
+              <a:rPr lang="sk-SK" sz="2000" dirty="0"/>
+              <a:t> a </a:t>
+            </a:r>
+            <a:r>
+              <a:rPr lang="sk-SK" sz="2000" i="1" dirty="0"/>
+              <a:t>Číny</a:t>
+            </a:r>
+            <a:r>
+              <a:rPr lang="sk-SK" sz="2000" dirty="0"/>
+              <a:t> štatisticky významne líši.</a:t>
+            </a:r>
+          </a:p>
+          <a:p>
             <a:r>
               <a:rPr lang="sk-SK" sz="2000" b="1" dirty="0">
                 <a:effectLst>
@@ -10441,23 +12098,14 @@
                   </a:outerShdw>
                 </a:effectLst>
               </a:rPr>
-              <a:t>2. </a:t>
+              <a:t>H3: </a:t>
             </a:r>
             <a:r>
               <a:rPr lang="sk-SK" sz="2000" dirty="0"/>
-              <a:t>Praktické poznatky o správaní akciových trhov počas období so zvýšeným rizikom, </a:t>
-            </a:r>
-          </a:p>
-          <a:p>
-            <a:pPr>
-              <a:buClr>
-                <a:schemeClr val="tx1">
-                  <a:lumMod val="95000"/>
-                  <a:lumOff val="5000"/>
-                </a:schemeClr>
-              </a:buClr>
-              <a:buSzPct val="110000"/>
-            </a:pPr>
+              <a:t>Asymetrické modely volatility dosahujú lepšiu výkonnosť počas krízových období ako symetrické modely volatility.</a:t>
+            </a:r>
+          </a:p>
+          <a:p>
             <a:r>
               <a:rPr lang="sk-SK" sz="2000" b="1" dirty="0">
                 <a:effectLst>
@@ -10468,47 +12116,14 @@
                   </a:outerShdw>
                 </a:effectLst>
               </a:rPr>
-              <a:t>3. </a:t>
+              <a:t>H4: </a:t>
             </a:r>
             <a:r>
               <a:rPr lang="sk-SK" sz="2000" dirty="0"/>
-              <a:t>Komparatívna analýza volatility akciových trhov </a:t>
-            </a:r>
-            <a:r>
-              <a:rPr lang="sk-SK" sz="2000" i="1" dirty="0"/>
-              <a:t>USA</a:t>
-            </a:r>
-            <a:r>
-              <a:rPr lang="sk-SK" sz="2000" dirty="0"/>
-              <a:t>, </a:t>
-            </a:r>
-            <a:r>
-              <a:rPr lang="sk-SK" sz="2000" i="1" dirty="0"/>
-              <a:t>Európy</a:t>
-            </a:r>
-            <a:r>
-              <a:rPr lang="sk-SK" sz="2000" dirty="0"/>
-              <a:t> a </a:t>
-            </a:r>
-            <a:r>
-              <a:rPr lang="sk-SK" sz="2000" i="1" dirty="0"/>
-              <a:t>Číny</a:t>
-            </a:r>
-            <a:r>
-              <a:rPr lang="sk-SK" sz="2000" dirty="0"/>
-              <a:t>,</a:t>
-            </a:r>
-          </a:p>
-          <a:p>
-            <a:pPr>
-              <a:buClr>
-                <a:schemeClr val="tx1">
-                  <a:lumMod val="95000"/>
-                  <a:lumOff val="5000"/>
-                </a:schemeClr>
-              </a:buClr>
-              <a:buSzPct val="110000"/>
-            </a:pPr>
+              <a:t>Metódy strojového a hlbokého učenia nemajú štatisticky významne vyššiu predikčnú výkonnosť ako vybrané ekonometrické modely volatility.</a:t>
+            </a:r>
+          </a:p>
+          <a:p>
             <a:r>
               <a:rPr lang="sk-SK" sz="2000" b="1" dirty="0">
                 <a:effectLst>
@@ -10519,65 +12134,11 @@
                   </a:outerShdw>
                 </a:effectLst>
               </a:rPr>
-              <a:t>4. </a:t>
+              <a:t>H5: </a:t>
             </a:r>
             <a:r>
               <a:rPr lang="sk-SK" sz="2000" dirty="0"/>
-              <a:t>Identifikácia faktorov, ktoré vplývajú na dynamiku volatility,</a:t>
-            </a:r>
-          </a:p>
-          <a:p>
-            <a:pPr>
-              <a:buClr>
-                <a:schemeClr val="tx1">
-                  <a:lumMod val="95000"/>
-                  <a:lumOff val="5000"/>
-                </a:schemeClr>
-              </a:buClr>
-              <a:buSzPct val="110000"/>
-            </a:pPr>
-            <a:r>
-              <a:rPr lang="sk-SK" sz="2000" b="1" dirty="0">
-                <a:effectLst>
-                  <a:outerShdw blurRad="38100" dist="38100" dir="2700000" algn="tl">
-                    <a:srgbClr val="000000">
-                      <a:alpha val="43137"/>
-                    </a:srgbClr>
-                  </a:outerShdw>
-                </a:effectLst>
-              </a:rPr>
-              <a:t>5. </a:t>
-            </a:r>
-            <a:r>
-              <a:rPr lang="sk-SK" sz="2000" dirty="0"/>
-              <a:t>Definícia metodiky pre identifikáciu vzorov v časových radoch akciových trhov s dôrazom na metódy umelej inteligencie,</a:t>
-            </a:r>
-          </a:p>
-          <a:p>
-            <a:pPr>
-              <a:buClr>
-                <a:schemeClr val="tx1">
-                  <a:lumMod val="95000"/>
-                  <a:lumOff val="5000"/>
-                </a:schemeClr>
-              </a:buClr>
-              <a:buSzPct val="110000"/>
-            </a:pPr>
-            <a:r>
-              <a:rPr lang="sk-SK" sz="2000" b="1" dirty="0">
-                <a:effectLst>
-                  <a:outerShdw blurRad="38100" dist="38100" dir="2700000" algn="tl">
-                    <a:srgbClr val="000000">
-                      <a:alpha val="43137"/>
-                    </a:srgbClr>
-                  </a:outerShdw>
-                </a:effectLst>
-              </a:rPr>
-              <a:t>6. </a:t>
-            </a:r>
-            <a:r>
-              <a:rPr lang="sk-SK" sz="2000" dirty="0"/>
-              <a:t>Poznatky o robustnosti definovanej metodiky vzhľadom na zdroj dát akciových indexov.</a:t>
+              <a:t>Identifikované vzory volatility akciových trhov sa pri použití porovnateľných zdrojov dát štatisticky významne nemenia.</a:t>
             </a:r>
           </a:p>
         </p:txBody>
@@ -10585,7 +12146,7 @@
     </p:spTree>
     <p:extLst>
       <p:ext uri="{BB962C8B-B14F-4D97-AF65-F5344CB8AC3E}">
-        <p14:creationId xmlns:p14="http://schemas.microsoft.com/office/powerpoint/2010/main" val="2170357634"/>
+        <p14:creationId xmlns:p14="http://schemas.microsoft.com/office/powerpoint/2010/main" val="1087255654"/>
       </p:ext>
     </p:extLst>
   </p:cSld>
@@ -10675,7 +12236,7 @@
         </p:xfrm>
         <a:graphic>
           <a:graphicData uri="http://schemas.openxmlformats.org/drawingml/2006/diagram">
-            <dgm:relIds xmlns:dgm="http://schemas.openxmlformats.org/drawingml/2006/diagram" xmlns:r="http://schemas.openxmlformats.org/officeDocument/2006/relationships" r:dm="rId2" r:lo="rId3" r:qs="rId4" r:cs="rId5"/>
+            <dgm:relIds xmlns:dgm="http://schemas.openxmlformats.org/drawingml/2006/diagram" xmlns:r="http://schemas.openxmlformats.org/officeDocument/2006/relationships" r:dm="rId3" r:lo="rId4" r:qs="rId5" r:cs="rId6"/>
           </a:graphicData>
         </a:graphic>
       </p:graphicFrame>
@@ -10946,7 +12507,7 @@
           <p:nvPr/>
         </p:nvPicPr>
         <p:blipFill>
-          <a:blip r:embed="rId2"/>
+          <a:blip r:embed="rId3"/>
           <a:stretch>
             <a:fillRect/>
           </a:stretch>
@@ -11178,7 +12739,7 @@
                   </a:outerShdw>
                 </a:effectLst>
               </a:rPr>
-              <a:t>Modely strojového učenia</a:t>
+              <a:t>Metódy umelej inteligencie</a:t>
             </a:r>
           </a:p>
           <a:p>
@@ -11748,4 +13309,319 @@
     </a:ext>
   </a:extLst>
 </a:theme>
+</file>
+
+<file path=ppt/theme/theme2.xml><?xml version="1.0" encoding="utf-8"?>
+<a:theme xmlns:a="http://schemas.openxmlformats.org/drawingml/2006/main" name="Motív Office">
+  <a:themeElements>
+    <a:clrScheme name="Office">
+      <a:dk1>
+        <a:sysClr val="windowText" lastClr="000000"/>
+      </a:dk1>
+      <a:lt1>
+        <a:sysClr val="window" lastClr="FFFFFF"/>
+      </a:lt1>
+      <a:dk2>
+        <a:srgbClr val="0E2841"/>
+      </a:dk2>
+      <a:lt2>
+        <a:srgbClr val="E8E8E8"/>
+      </a:lt2>
+      <a:accent1>
+        <a:srgbClr val="156082"/>
+      </a:accent1>
+      <a:accent2>
+        <a:srgbClr val="E97132"/>
+      </a:accent2>
+      <a:accent3>
+        <a:srgbClr val="196B24"/>
+      </a:accent3>
+      <a:accent4>
+        <a:srgbClr val="0F9ED5"/>
+      </a:accent4>
+      <a:accent5>
+        <a:srgbClr val="A02B93"/>
+      </a:accent5>
+      <a:accent6>
+        <a:srgbClr val="4EA72E"/>
+      </a:accent6>
+      <a:hlink>
+        <a:srgbClr val="467886"/>
+      </a:hlink>
+      <a:folHlink>
+        <a:srgbClr val="96607D"/>
+      </a:folHlink>
+    </a:clrScheme>
+    <a:fontScheme name="Office">
+      <a:majorFont>
+        <a:latin typeface="Aptos Display" panose="02110004020202020204"/>
+        <a:ea typeface=""/>
+        <a:cs typeface=""/>
+        <a:font script="Jpan" typeface="游ゴシック Light"/>
+        <a:font script="Hang" typeface="맑은 고딕"/>
+        <a:font script="Hans" typeface="等线 Light"/>
+        <a:font script="Hant" typeface="新細明體"/>
+        <a:font script="Arab" typeface="Times New Roman"/>
+        <a:font script="Hebr" typeface="Times New Roman"/>
+        <a:font script="Thai" typeface="Angsana New"/>
+        <a:font script="Ethi" typeface="Nyala"/>
+        <a:font script="Beng" typeface="Vrinda"/>
+        <a:font script="Gujr" typeface="Shruti"/>
+        <a:font script="Khmr" typeface="MoolBoran"/>
+        <a:font script="Knda" typeface="Tunga"/>
+        <a:font script="Guru" typeface="Raavi"/>
+        <a:font script="Cans" typeface="Euphemia"/>
+        <a:font script="Cher" typeface="Plantagenet Cherokee"/>
+        <a:font script="Yiii" typeface="Microsoft Yi Baiti"/>
+        <a:font script="Tibt" typeface="Microsoft Himalaya"/>
+        <a:font script="Thaa" typeface="MV Boli"/>
+        <a:font script="Deva" typeface="Mangal"/>
+        <a:font script="Telu" typeface="Gautami"/>
+        <a:font script="Taml" typeface="Latha"/>
+        <a:font script="Syrc" typeface="Estrangelo Edessa"/>
+        <a:font script="Orya" typeface="Kalinga"/>
+        <a:font script="Mlym" typeface="Kartika"/>
+        <a:font script="Laoo" typeface="DokChampa"/>
+        <a:font script="Sinh" typeface="Iskoola Pota"/>
+        <a:font script="Mong" typeface="Mongolian Baiti"/>
+        <a:font script="Viet" typeface="Times New Roman"/>
+        <a:font script="Uigh" typeface="Microsoft Uighur"/>
+        <a:font script="Geor" typeface="Sylfaen"/>
+        <a:font script="Armn" typeface="Arial"/>
+        <a:font script="Bugi" typeface="Leelawadee UI"/>
+        <a:font script="Bopo" typeface="Microsoft JhengHei"/>
+        <a:font script="Java" typeface="Javanese Text"/>
+        <a:font script="Lisu" typeface="Segoe UI"/>
+        <a:font script="Mymr" typeface="Myanmar Text"/>
+        <a:font script="Nkoo" typeface="Ebrima"/>
+        <a:font script="Olck" typeface="Nirmala UI"/>
+        <a:font script="Osma" typeface="Ebrima"/>
+        <a:font script="Phag" typeface="Phagspa"/>
+        <a:font script="Syrn" typeface="Estrangelo Edessa"/>
+        <a:font script="Syrj" typeface="Estrangelo Edessa"/>
+        <a:font script="Syre" typeface="Estrangelo Edessa"/>
+        <a:font script="Sora" typeface="Nirmala UI"/>
+        <a:font script="Tale" typeface="Microsoft Tai Le"/>
+        <a:font script="Talu" typeface="Microsoft New Tai Lue"/>
+        <a:font script="Tfng" typeface="Ebrima"/>
+      </a:majorFont>
+      <a:minorFont>
+        <a:latin typeface="Aptos" panose="02110004020202020204"/>
+        <a:ea typeface=""/>
+        <a:cs typeface=""/>
+        <a:font script="Jpan" typeface="游ゴシック"/>
+        <a:font script="Hang" typeface="맑은 고딕"/>
+        <a:font script="Hans" typeface="等线"/>
+        <a:font script="Hant" typeface="新細明體"/>
+        <a:font script="Arab" typeface="Arial"/>
+        <a:font script="Hebr" typeface="Arial"/>
+        <a:font script="Thai" typeface="Cordia New"/>
+        <a:font script="Ethi" typeface="Nyala"/>
+        <a:font script="Beng" typeface="Vrinda"/>
+        <a:font script="Gujr" typeface="Shruti"/>
+        <a:font script="Khmr" typeface="DaunPenh"/>
+        <a:font script="Knda" typeface="Tunga"/>
+        <a:font script="Guru" typeface="Raavi"/>
+        <a:font script="Cans" typeface="Euphemia"/>
+        <a:font script="Cher" typeface="Plantagenet Cherokee"/>
+        <a:font script="Yiii" typeface="Microsoft Yi Baiti"/>
+        <a:font script="Tibt" typeface="Microsoft Himalaya"/>
+        <a:font script="Thaa" typeface="MV Boli"/>
+        <a:font script="Deva" typeface="Mangal"/>
+        <a:font script="Telu" typeface="Gautami"/>
+        <a:font script="Taml" typeface="Latha"/>
+        <a:font script="Syrc" typeface="Estrangelo Edessa"/>
+        <a:font script="Orya" typeface="Kalinga"/>
+        <a:font script="Mlym" typeface="Kartika"/>
+        <a:font script="Laoo" typeface="DokChampa"/>
+        <a:font script="Sinh" typeface="Iskoola Pota"/>
+        <a:font script="Mong" typeface="Mongolian Baiti"/>
+        <a:font script="Viet" typeface="Arial"/>
+        <a:font script="Uigh" typeface="Microsoft Uighur"/>
+        <a:font script="Geor" typeface="Sylfaen"/>
+        <a:font script="Armn" typeface="Arial"/>
+        <a:font script="Bugi" typeface="Leelawadee UI"/>
+        <a:font script="Bopo" typeface="Microsoft JhengHei"/>
+        <a:font script="Java" typeface="Javanese Text"/>
+        <a:font script="Lisu" typeface="Segoe UI"/>
+        <a:font script="Mymr" typeface="Myanmar Text"/>
+        <a:font script="Nkoo" typeface="Ebrima"/>
+        <a:font script="Olck" typeface="Nirmala UI"/>
+        <a:font script="Osma" typeface="Ebrima"/>
+        <a:font script="Phag" typeface="Phagspa"/>
+        <a:font script="Syrn" typeface="Estrangelo Edessa"/>
+        <a:font script="Syrj" typeface="Estrangelo Edessa"/>
+        <a:font script="Syre" typeface="Estrangelo Edessa"/>
+        <a:font script="Sora" typeface="Nirmala UI"/>
+        <a:font script="Tale" typeface="Microsoft Tai Le"/>
+        <a:font script="Talu" typeface="Microsoft New Tai Lue"/>
+        <a:font script="Tfng" typeface="Ebrima"/>
+      </a:minorFont>
+    </a:fontScheme>
+    <a:fmtScheme name="Office">
+      <a:fillStyleLst>
+        <a:solidFill>
+          <a:schemeClr val="phClr"/>
+        </a:solidFill>
+        <a:gradFill rotWithShape="1">
+          <a:gsLst>
+            <a:gs pos="0">
+              <a:schemeClr val="phClr">
+                <a:lumMod val="110000"/>
+                <a:satMod val="105000"/>
+                <a:tint val="67000"/>
+              </a:schemeClr>
+            </a:gs>
+            <a:gs pos="50000">
+              <a:schemeClr val="phClr">
+                <a:lumMod val="105000"/>
+                <a:satMod val="103000"/>
+                <a:tint val="73000"/>
+              </a:schemeClr>
+            </a:gs>
+            <a:gs pos="100000">
+              <a:schemeClr val="phClr">
+                <a:lumMod val="105000"/>
+                <a:satMod val="109000"/>
+                <a:tint val="81000"/>
+              </a:schemeClr>
+            </a:gs>
+          </a:gsLst>
+          <a:lin ang="5400000" scaled="0"/>
+        </a:gradFill>
+        <a:gradFill rotWithShape="1">
+          <a:gsLst>
+            <a:gs pos="0">
+              <a:schemeClr val="phClr">
+                <a:satMod val="103000"/>
+                <a:lumMod val="102000"/>
+                <a:tint val="94000"/>
+              </a:schemeClr>
+            </a:gs>
+            <a:gs pos="50000">
+              <a:schemeClr val="phClr">
+                <a:satMod val="110000"/>
+                <a:lumMod val="100000"/>
+                <a:shade val="100000"/>
+              </a:schemeClr>
+            </a:gs>
+            <a:gs pos="100000">
+              <a:schemeClr val="phClr">
+                <a:lumMod val="99000"/>
+                <a:satMod val="120000"/>
+                <a:shade val="78000"/>
+              </a:schemeClr>
+            </a:gs>
+          </a:gsLst>
+          <a:lin ang="5400000" scaled="0"/>
+        </a:gradFill>
+      </a:fillStyleLst>
+      <a:lnStyleLst>
+        <a:ln w="12700" cap="flat" cmpd="sng" algn="ctr">
+          <a:solidFill>
+            <a:schemeClr val="phClr"/>
+          </a:solidFill>
+          <a:prstDash val="solid"/>
+          <a:miter lim="800000"/>
+        </a:ln>
+        <a:ln w="19050" cap="flat" cmpd="sng" algn="ctr">
+          <a:solidFill>
+            <a:schemeClr val="phClr"/>
+          </a:solidFill>
+          <a:prstDash val="solid"/>
+          <a:miter lim="800000"/>
+        </a:ln>
+        <a:ln w="25400" cap="flat" cmpd="sng" algn="ctr">
+          <a:solidFill>
+            <a:schemeClr val="phClr"/>
+          </a:solidFill>
+          <a:prstDash val="solid"/>
+          <a:miter lim="800000"/>
+        </a:ln>
+      </a:lnStyleLst>
+      <a:effectStyleLst>
+        <a:effectStyle>
+          <a:effectLst/>
+        </a:effectStyle>
+        <a:effectStyle>
+          <a:effectLst/>
+        </a:effectStyle>
+        <a:effectStyle>
+          <a:effectLst>
+            <a:outerShdw blurRad="57150" dist="19050" dir="5400000" algn="ctr" rotWithShape="0">
+              <a:srgbClr val="000000">
+                <a:alpha val="63000"/>
+              </a:srgbClr>
+            </a:outerShdw>
+          </a:effectLst>
+        </a:effectStyle>
+      </a:effectStyleLst>
+      <a:bgFillStyleLst>
+        <a:solidFill>
+          <a:schemeClr val="phClr"/>
+        </a:solidFill>
+        <a:solidFill>
+          <a:schemeClr val="phClr">
+            <a:tint val="95000"/>
+            <a:satMod val="170000"/>
+          </a:schemeClr>
+        </a:solidFill>
+        <a:gradFill rotWithShape="1">
+          <a:gsLst>
+            <a:gs pos="0">
+              <a:schemeClr val="phClr">
+                <a:tint val="93000"/>
+                <a:satMod val="150000"/>
+                <a:shade val="98000"/>
+                <a:lumMod val="102000"/>
+              </a:schemeClr>
+            </a:gs>
+            <a:gs pos="50000">
+              <a:schemeClr val="phClr">
+                <a:tint val="98000"/>
+                <a:satMod val="130000"/>
+                <a:shade val="90000"/>
+                <a:lumMod val="103000"/>
+              </a:schemeClr>
+            </a:gs>
+            <a:gs pos="100000">
+              <a:schemeClr val="phClr">
+                <a:shade val="63000"/>
+                <a:satMod val="120000"/>
+              </a:schemeClr>
+            </a:gs>
+          </a:gsLst>
+          <a:lin ang="5400000" scaled="0"/>
+        </a:gradFill>
+      </a:bgFillStyleLst>
+    </a:fmtScheme>
+  </a:themeElements>
+  <a:objectDefaults>
+    <a:lnDef>
+      <a:spPr/>
+      <a:bodyPr/>
+      <a:lstStyle/>
+      <a:style>
+        <a:lnRef idx="2">
+          <a:schemeClr val="accent1"/>
+        </a:lnRef>
+        <a:fillRef idx="0">
+          <a:schemeClr val="accent1"/>
+        </a:fillRef>
+        <a:effectRef idx="1">
+          <a:schemeClr val="accent1"/>
+        </a:effectRef>
+        <a:fontRef idx="minor">
+          <a:schemeClr val="tx1"/>
+        </a:fontRef>
+      </a:style>
+    </a:lnDef>
+  </a:objectDefaults>
+  <a:extraClrSchemeLst/>
+  <a:extLst>
+    <a:ext uri="{05A4C25C-085E-4340-85A3-A5531E510DB2}">
+      <thm15:themeFamily xmlns:thm15="http://schemas.microsoft.com/office/thememl/2012/main" name="Office Theme" id="{2E142A2C-CD16-42D6-873A-C26D2A0506FA}" vid="{1BDDFF52-6CD6-40A5-AB3C-68EB2F1E4D0A}"/>
+    </a:ext>
+  </a:extLst>
+</a:theme>
 </file>
</xml_diff>

<commit_message>
Prezentáciaaaa zas a znova
</commit_message>
<xml_diff>
--- a/Identifikácia vzorov v časových radoch pre komparáciu volatility.pptx
+++ b/Identifikácia vzorov v časových radoch pre komparáciu volatility.pptx
@@ -1523,47 +1523,6 @@
         </a:p>
       </dgm:t>
     </dgm:pt>
-    <dgm:pt modelId="{FBC92019-F9D6-44C7-8FEB-8E1D787D9847}">
-      <dgm:prSet phldrT="[Text]" phldr="0" custT="1"/>
-      <dgm:spPr/>
-      <dgm:t>
-        <a:bodyPr/>
-        <a:lstStyle/>
-        <a:p>
-          <a:pPr>
-            <a:lnSpc>
-              <a:spcPct val="100000"/>
-            </a:lnSpc>
-          </a:pPr>
-          <a:r>
-            <a:rPr lang="sk-SK" sz="1400" dirty="0"/>
-            <a:t>Volatilita</a:t>
-          </a:r>
-        </a:p>
-      </dgm:t>
-    </dgm:pt>
-    <dgm:pt modelId="{5EAB6389-7D50-4C94-99A4-37938FFC0698}" type="parTrans" cxnId="{92279661-C1E7-4D1F-9157-1BD84C41BF85}">
-      <dgm:prSet/>
-      <dgm:spPr/>
-      <dgm:t>
-        <a:bodyPr/>
-        <a:lstStyle/>
-        <a:p>
-          <a:endParaRPr lang="sk-SK"/>
-        </a:p>
-      </dgm:t>
-    </dgm:pt>
-    <dgm:pt modelId="{EE1255BA-5F89-4775-9AE5-613A99589471}" type="sibTrans" cxnId="{92279661-C1E7-4D1F-9157-1BD84C41BF85}">
-      <dgm:prSet/>
-      <dgm:spPr/>
-      <dgm:t>
-        <a:bodyPr/>
-        <a:lstStyle/>
-        <a:p>
-          <a:endParaRPr lang="sk-SK"/>
-        </a:p>
-      </dgm:t>
-    </dgm:pt>
     <dgm:pt modelId="{609221ED-82FD-45D9-955E-69D98C9F9837}">
       <dgm:prSet phldrT="[Text]" phldr="0" custT="1"/>
       <dgm:spPr/>
@@ -1882,7 +1841,6 @@
     <dgm:cxn modelId="{EF930D35-4B86-4E80-85DC-7B6BC7AA9496}" srcId="{9979E402-2F88-436A-8282-66EF53786664}" destId="{73AD1036-9A58-4EFE-A690-768795CB6028}" srcOrd="1" destOrd="0" parTransId="{D74B432F-AB74-4B64-BFA2-E32BDA98B222}" sibTransId="{408C3476-FF68-4201-93EA-3E782D733A5A}"/>
     <dgm:cxn modelId="{5EA18F3F-8C95-4516-A78B-E998C72E980A}" type="presOf" srcId="{59B08BBC-3ABB-47D1-B928-7D3326411A7C}" destId="{ADB04D02-A97C-4659-BAB1-BFD732875B6F}" srcOrd="0" destOrd="0" presId="urn:microsoft.com/office/officeart/2005/8/layout/hProcess4"/>
     <dgm:cxn modelId="{2F37565F-A296-488B-93B3-B1A833772821}" type="presOf" srcId="{5A9B94D9-D4F7-4D1D-B7A5-E4EBAEBE5076}" destId="{F19BD381-30C3-4201-B50A-E41684C9478F}" srcOrd="0" destOrd="0" presId="urn:microsoft.com/office/officeart/2005/8/layout/hProcess4"/>
-    <dgm:cxn modelId="{92279661-C1E7-4D1F-9157-1BD84C41BF85}" srcId="{2207399F-F7A9-4246-825E-CB2F59081A8E}" destId="{FBC92019-F9D6-44C7-8FEB-8E1D787D9847}" srcOrd="1" destOrd="0" parTransId="{5EAB6389-7D50-4C94-99A4-37938FFC0698}" sibTransId="{EE1255BA-5F89-4775-9AE5-613A99589471}"/>
     <dgm:cxn modelId="{BEB58F67-6203-4934-ACB6-24E5DE29A637}" srcId="{2207399F-F7A9-4246-825E-CB2F59081A8E}" destId="{3ED2CA7C-8CF3-4C7D-B586-70BE48490C21}" srcOrd="0" destOrd="0" parTransId="{30A02569-3B28-4898-83E1-9F52CF2D5DF7}" sibTransId="{65491649-8A43-4755-8BC5-745B3DE7A686}"/>
     <dgm:cxn modelId="{23328F69-7A3A-4E22-9E08-42F9C489C67F}" srcId="{C29477DB-93CB-41C5-979C-064DF5F4039B}" destId="{9AACA625-023E-4357-97C3-04906BC41DD8}" srcOrd="1" destOrd="0" parTransId="{0AB24F2C-DCB6-41E0-8CF4-8B7B503E0D35}" sibTransId="{9615B57A-14EC-4E34-ACAE-C271D4D87DE9}"/>
     <dgm:cxn modelId="{DB8EAE6C-7106-45F1-BF84-82255282170A}" type="presOf" srcId="{1B2331C3-4ED8-496E-B08D-D0298EC66B33}" destId="{F19BD381-30C3-4201-B50A-E41684C9478F}" srcOrd="0" destOrd="3" presId="urn:microsoft.com/office/officeart/2005/8/layout/hProcess4"/>
@@ -1891,7 +1849,6 @@
     <dgm:cxn modelId="{8583DF4F-4093-4EB7-BC34-9DEF845ECFD0}" type="presOf" srcId="{0B006AC3-28C8-4288-AFED-91FA3D0A00F9}" destId="{7B6A1E41-DCFE-4AC5-8D88-041D7A647606}" srcOrd="0" destOrd="1" presId="urn:microsoft.com/office/officeart/2005/8/layout/hProcess4"/>
     <dgm:cxn modelId="{E434B475-7EA1-44D2-8B1A-F82B4C50954D}" type="presOf" srcId="{9979E402-2F88-436A-8282-66EF53786664}" destId="{E878FD4D-12B7-458B-BC0F-B75BEB791108}" srcOrd="0" destOrd="0" presId="urn:microsoft.com/office/officeart/2005/8/layout/hProcess4"/>
     <dgm:cxn modelId="{83FA1876-1988-4AA7-8772-424EBC865BEE}" srcId="{4EF5B21F-0522-4B37-85D6-CEB430CCB426}" destId="{DE3AD505-65C0-49B0-BBA3-107F8FE3DB83}" srcOrd="0" destOrd="0" parTransId="{3FB8894D-9D06-4462-954B-2CE4DB8E1B44}" sibTransId="{A4CBCBDC-32A9-4FEC-88AF-47A54C5CE209}"/>
-    <dgm:cxn modelId="{DDBD4F76-6AA7-4B92-9805-2A666B8665F2}" type="presOf" srcId="{FBC92019-F9D6-44C7-8FEB-8E1D787D9847}" destId="{46A5BD50-A357-43EB-900E-7628F4E860EB}" srcOrd="0" destOrd="1" presId="urn:microsoft.com/office/officeart/2005/8/layout/hProcess4"/>
     <dgm:cxn modelId="{C4486479-08EB-4FC4-8DCA-1090C522E791}" type="presOf" srcId="{1B2331C3-4ED8-496E-B08D-D0298EC66B33}" destId="{2B0884EC-019C-489D-80AA-7566A7966A30}" srcOrd="1" destOrd="3" presId="urn:microsoft.com/office/officeart/2005/8/layout/hProcess4"/>
     <dgm:cxn modelId="{2DE89C59-6E2F-45BA-9D96-C20A8E33861B}" type="presOf" srcId="{609221ED-82FD-45D9-955E-69D98C9F9837}" destId="{2B0884EC-019C-489D-80AA-7566A7966A30}" srcOrd="1" destOrd="2" presId="urn:microsoft.com/office/officeart/2005/8/layout/hProcess4"/>
     <dgm:cxn modelId="{4532DF9A-C60F-4A31-9302-868AC9FD0915}" type="presOf" srcId="{8B704CD4-C4A3-4CA8-9E6D-3F5A58FB5A6E}" destId="{850FA6B7-9A4F-4AA5-BDED-68AE9D7593C5}" srcOrd="0" destOrd="0" presId="urn:microsoft.com/office/officeart/2005/8/layout/hProcess4"/>
@@ -1906,7 +1863,7 @@
     <dgm:cxn modelId="{6E8D91AF-8DE7-4F4E-8EAB-E5CED69CEC1F}" type="presOf" srcId="{9847EFBA-07E4-4A28-9C1A-E7667B923BB5}" destId="{1578868B-2CAF-4820-BE2E-8D12F7F7A919}" srcOrd="0" destOrd="0" presId="urn:microsoft.com/office/officeart/2005/8/layout/hProcess4"/>
     <dgm:cxn modelId="{89E99CB0-D87A-4B3C-9588-85E36DE4E5D4}" type="presOf" srcId="{9AACA625-023E-4357-97C3-04906BC41DD8}" destId="{ADB04D02-A97C-4659-BAB1-BFD732875B6F}" srcOrd="0" destOrd="1" presId="urn:microsoft.com/office/officeart/2005/8/layout/hProcess4"/>
     <dgm:cxn modelId="{621691B4-DDBD-4DF2-B1B0-FB701B9853D5}" type="presOf" srcId="{A3A0FADB-9E1C-46FA-9954-1A7B414B35B9}" destId="{D401E58F-260B-48C4-8ED1-6DB73FD4E661}" srcOrd="1" destOrd="1" presId="urn:microsoft.com/office/officeart/2005/8/layout/hProcess4"/>
-    <dgm:cxn modelId="{16ECBFB4-04FA-4F01-9B73-FB666D5B3594}" type="presOf" srcId="{39031FE6-9489-43E5-BCCE-9368A5102F41}" destId="{0F7E9FD4-6D4A-4F6B-86E7-3179B41C32BE}" srcOrd="1" destOrd="2" presId="urn:microsoft.com/office/officeart/2005/8/layout/hProcess4"/>
+    <dgm:cxn modelId="{16ECBFB4-04FA-4F01-9B73-FB666D5B3594}" type="presOf" srcId="{39031FE6-9489-43E5-BCCE-9368A5102F41}" destId="{0F7E9FD4-6D4A-4F6B-86E7-3179B41C32BE}" srcOrd="1" destOrd="1" presId="urn:microsoft.com/office/officeart/2005/8/layout/hProcess4"/>
     <dgm:cxn modelId="{B5D0ECB7-E566-4057-A1EA-FD252152DFE1}" type="presOf" srcId="{59B08BBC-3ABB-47D1-B928-7D3326411A7C}" destId="{7AE20833-C756-4510-9EF0-F24DE50F50DA}" srcOrd="1" destOrd="0" presId="urn:microsoft.com/office/officeart/2005/8/layout/hProcess4"/>
     <dgm:cxn modelId="{3CB867B9-6F43-4AB6-9530-DB6C5EF59301}" srcId="{D6FB274B-FC90-4E83-AEF4-3C4FAD353500}" destId="{0B006AC3-28C8-4288-AFED-91FA3D0A00F9}" srcOrd="1" destOrd="0" parTransId="{3666285E-AE42-426B-A018-E0BA7E841619}" sibTransId="{80AA56DF-E813-4B21-A7F1-6FEC4A8ABA5B}"/>
     <dgm:cxn modelId="{512E31BD-BF4D-4053-8171-89D1D2BD3D55}" type="presOf" srcId="{0B006AC3-28C8-4288-AFED-91FA3D0A00F9}" destId="{B6E2E50B-E13E-4164-8844-C48D2241F28F}" srcOrd="1" destOrd="1" presId="urn:microsoft.com/office/officeart/2005/8/layout/hProcess4"/>
@@ -1914,18 +1871,17 @@
     <dgm:cxn modelId="{A76D05C4-A12A-4B98-9194-3F92D8D6E43A}" srcId="{B665338B-645B-41AE-983D-65FFD2CDBEFF}" destId="{D6FB274B-FC90-4E83-AEF4-3C4FAD353500}" srcOrd="0" destOrd="0" parTransId="{5A19F18F-4921-423D-81BF-A1FD0D5AC97B}" sibTransId="{8B704CD4-C4A3-4CA8-9E6D-3F5A58FB5A6E}"/>
     <dgm:cxn modelId="{500E1CC5-E3EB-48CE-81C8-01B2FF0977A1}" type="presOf" srcId="{609221ED-82FD-45D9-955E-69D98C9F9837}" destId="{F19BD381-30C3-4201-B50A-E41684C9478F}" srcOrd="0" destOrd="2" presId="urn:microsoft.com/office/officeart/2005/8/layout/hProcess4"/>
     <dgm:cxn modelId="{E51FFEC5-0C48-4BFD-9DD2-0E5F0D9F9B63}" srcId="{B665338B-645B-41AE-983D-65FFD2CDBEFF}" destId="{2207399F-F7A9-4246-825E-CB2F59081A8E}" srcOrd="1" destOrd="0" parTransId="{0BBDA673-1136-4713-8084-109E95915A75}" sibTransId="{4151D506-449B-4309-95E1-51332BF9EED7}"/>
-    <dgm:cxn modelId="{CA233CC6-92B2-4A88-BEFC-46B83D41E595}" srcId="{2207399F-F7A9-4246-825E-CB2F59081A8E}" destId="{39031FE6-9489-43E5-BCCE-9368A5102F41}" srcOrd="2" destOrd="0" parTransId="{8B494894-2007-4090-BB37-185754316FE5}" sibTransId="{894F75BD-961D-4E6E-8B14-1223A8001890}"/>
+    <dgm:cxn modelId="{CA233CC6-92B2-4A88-BEFC-46B83D41E595}" srcId="{2207399F-F7A9-4246-825E-CB2F59081A8E}" destId="{39031FE6-9489-43E5-BCCE-9368A5102F41}" srcOrd="1" destOrd="0" parTransId="{8B494894-2007-4090-BB37-185754316FE5}" sibTransId="{894F75BD-961D-4E6E-8B14-1223A8001890}"/>
     <dgm:cxn modelId="{47FFA8C6-5991-4EDA-8402-967CDCF06D51}" srcId="{4EF5B21F-0522-4B37-85D6-CEB430CCB426}" destId="{A3A0FADB-9E1C-46FA-9954-1A7B414B35B9}" srcOrd="1" destOrd="0" parTransId="{38FAC2C9-419E-4EF5-879C-35B6091251F6}" sibTransId="{F5341326-D575-46DC-A6B0-BD344AD6EE25}"/>
     <dgm:cxn modelId="{A8E619CC-CD02-4E00-B8C5-610274244D24}" type="presOf" srcId="{C29477DB-93CB-41C5-979C-064DF5F4039B}" destId="{6B4282B9-062B-41C5-898A-A66339751090}" srcOrd="0" destOrd="0" presId="urn:microsoft.com/office/officeart/2005/8/layout/hProcess4"/>
     <dgm:cxn modelId="{92BD74CD-A52D-439A-B938-51B066954595}" srcId="{B665338B-645B-41AE-983D-65FFD2CDBEFF}" destId="{C29477DB-93CB-41C5-979C-064DF5F4039B}" srcOrd="4" destOrd="0" parTransId="{146D272C-43EF-4C36-BDDC-49E2C0F2BD02}" sibTransId="{D3BF079C-D04F-4E30-9314-BE8D4456213A}"/>
-    <dgm:cxn modelId="{B17DDED1-670D-4B61-B3E7-F712F73AE8BF}" type="presOf" srcId="{39031FE6-9489-43E5-BCCE-9368A5102F41}" destId="{46A5BD50-A357-43EB-900E-7628F4E860EB}" srcOrd="0" destOrd="2" presId="urn:microsoft.com/office/officeart/2005/8/layout/hProcess4"/>
+    <dgm:cxn modelId="{B17DDED1-670D-4B61-B3E7-F712F73AE8BF}" type="presOf" srcId="{39031FE6-9489-43E5-BCCE-9368A5102F41}" destId="{46A5BD50-A357-43EB-900E-7628F4E860EB}" srcOrd="0" destOrd="1" presId="urn:microsoft.com/office/officeart/2005/8/layout/hProcess4"/>
     <dgm:cxn modelId="{6A727CD2-775C-4511-B002-9C281868F8FC}" type="presOf" srcId="{8D030EC8-A772-4D56-8F07-0AE23381547A}" destId="{7B6A1E41-DCFE-4AC5-8D88-041D7A647606}" srcOrd="0" destOrd="0" presId="urn:microsoft.com/office/officeart/2005/8/layout/hProcess4"/>
     <dgm:cxn modelId="{9768A2D3-4C6C-49DA-8A2F-78843B19EEF7}" type="presOf" srcId="{73AD1036-9A58-4EFE-A690-768795CB6028}" destId="{F19BD381-30C3-4201-B50A-E41684C9478F}" srcOrd="0" destOrd="1" presId="urn:microsoft.com/office/officeart/2005/8/layout/hProcess4"/>
     <dgm:cxn modelId="{897409D9-192B-4EDF-8972-02F349E168B0}" type="presOf" srcId="{4EF5B21F-0522-4B37-85D6-CEB430CCB426}" destId="{3EA60A08-F209-4DFD-A8C0-33D58C80F67D}" srcOrd="0" destOrd="0" presId="urn:microsoft.com/office/officeart/2005/8/layout/hProcess4"/>
     <dgm:cxn modelId="{76A112EF-4F15-4699-96ED-8440111B0D2F}" type="presOf" srcId="{3ED2CA7C-8CF3-4C7D-B586-70BE48490C21}" destId="{0F7E9FD4-6D4A-4F6B-86E7-3179B41C32BE}" srcOrd="1" destOrd="0" presId="urn:microsoft.com/office/officeart/2005/8/layout/hProcess4"/>
     <dgm:cxn modelId="{DAEEB7EF-C8BB-4E20-B08B-BB49E4076AEB}" type="presOf" srcId="{4151D506-449B-4309-95E1-51332BF9EED7}" destId="{DB00C555-2EA1-4D87-A59D-2B8C4B0D5343}" srcOrd="0" destOrd="0" presId="urn:microsoft.com/office/officeart/2005/8/layout/hProcess4"/>
     <dgm:cxn modelId="{09CF8BF3-4050-4D48-B720-9B954225D1AE}" type="presOf" srcId="{B665338B-645B-41AE-983D-65FFD2CDBEFF}" destId="{0988CE5C-27CF-4DBE-A10F-ED07BCA1B13B}" srcOrd="0" destOrd="0" presId="urn:microsoft.com/office/officeart/2005/8/layout/hProcess4"/>
-    <dgm:cxn modelId="{BEA7AAF9-73A8-40BA-9938-1032F9ABF083}" type="presOf" srcId="{FBC92019-F9D6-44C7-8FEB-8E1D787D9847}" destId="{0F7E9FD4-6D4A-4F6B-86E7-3179B41C32BE}" srcOrd="1" destOrd="1" presId="urn:microsoft.com/office/officeart/2005/8/layout/hProcess4"/>
     <dgm:cxn modelId="{8E02247B-249E-4971-8582-4D578DC693B5}" type="presParOf" srcId="{0988CE5C-27CF-4DBE-A10F-ED07BCA1B13B}" destId="{3B42B861-20D8-4D43-90F3-4BC0C7641FEA}" srcOrd="0" destOrd="0" presId="urn:microsoft.com/office/officeart/2005/8/layout/hProcess4"/>
     <dgm:cxn modelId="{8A984E5A-25BC-457C-8A35-C399DC0FA32C}" type="presParOf" srcId="{0988CE5C-27CF-4DBE-A10F-ED07BCA1B13B}" destId="{130535EF-3ED6-4707-8CDF-434B62E24FB2}" srcOrd="1" destOrd="0" presId="urn:microsoft.com/office/officeart/2005/8/layout/hProcess4"/>
     <dgm:cxn modelId="{6BDDB780-B06A-4A02-A045-9E0ED006ED79}" type="presParOf" srcId="{0988CE5C-27CF-4DBE-A10F-ED07BCA1B13B}" destId="{1B16AE6F-9C06-44DE-B7B3-443002962661}" srcOrd="2" destOrd="0" presId="urn:microsoft.com/office/officeart/2005/8/layout/hProcess4"/>
@@ -2290,24 +2246,6 @@
           <a:r>
             <a:rPr lang="sk-SK" sz="1400" kern="1200" dirty="0"/>
             <a:t>Log výnosy</a:t>
-          </a:r>
-        </a:p>
-        <a:p>
-          <a:pPr marL="114300" lvl="1" indent="-114300" algn="l" defTabSz="622300">
-            <a:lnSpc>
-              <a:spcPct val="100000"/>
-            </a:lnSpc>
-            <a:spcBef>
-              <a:spcPct val="0"/>
-            </a:spcBef>
-            <a:spcAft>
-              <a:spcPct val="15000"/>
-            </a:spcAft>
-            <a:buChar char="•"/>
-          </a:pPr>
-          <a:r>
-            <a:rPr lang="sk-SK" sz="1400" kern="1200" dirty="0"/>
-            <a:t>Volatilita</a:t>
           </a:r>
         </a:p>
         <a:p>
@@ -4823,7 +4761,7 @@
           <a:p>
             <a:fld id="{AD9B504B-8E04-47AE-BBD5-0260BCE63BC0}" type="datetimeFigureOut">
               <a:rPr lang="sk-SK" smtClean="0"/>
-              <a:t>21. 6. 2026</a:t>
+              <a:t>24. 6. 2026</a:t>
             </a:fld>
             <a:endParaRPr lang="sk-SK"/>
           </a:p>
@@ -5539,6 +5477,203 @@
               <a:t>Podrobnejšie popísať navrhovanú metodiku výskumu.</a:t>
             </a:r>
           </a:p>
+          <a:p>
+            <a:endParaRPr lang="sk-SK" dirty="0"/>
+          </a:p>
+          <a:p>
+            <a:r>
+              <a:rPr lang="sk-SK" dirty="0"/>
+              <a:t>Spomenúť:</a:t>
+            </a:r>
+          </a:p>
+          <a:p>
+            <a:r>
+              <a:rPr lang="sk-SK" sz="1200" kern="1200" dirty="0">
+                <a:solidFill>
+                  <a:schemeClr val="tx1"/>
+                </a:solidFill>
+                <a:effectLst/>
+                <a:latin typeface="+mn-lt"/>
+                <a:ea typeface="+mn-ea"/>
+                <a:cs typeface="+mn-cs"/>
+              </a:rPr>
+              <a:t>„Dáta budú transformované na logaritmické výnosy a následne budú analyzované ich vlastnosti ako </a:t>
+            </a:r>
+            <a:r>
+              <a:rPr lang="sk-SK" sz="1200" kern="1200" dirty="0" err="1">
+                <a:solidFill>
+                  <a:schemeClr val="tx1"/>
+                </a:solidFill>
+                <a:effectLst/>
+                <a:latin typeface="+mn-lt"/>
+                <a:ea typeface="+mn-ea"/>
+                <a:cs typeface="+mn-cs"/>
+              </a:rPr>
+              <a:t>stacionarita</a:t>
+            </a:r>
+            <a:r>
+              <a:rPr lang="sk-SK" sz="1200" kern="1200" dirty="0">
+                <a:solidFill>
+                  <a:schemeClr val="tx1"/>
+                </a:solidFill>
+                <a:effectLst/>
+                <a:latin typeface="+mn-lt"/>
+                <a:ea typeface="+mn-ea"/>
+                <a:cs typeface="+mn-cs"/>
+              </a:rPr>
+              <a:t>, </a:t>
+            </a:r>
+            <a:r>
+              <a:rPr lang="sk-SK" sz="1200" kern="1200" dirty="0" err="1">
+                <a:solidFill>
+                  <a:schemeClr val="tx1"/>
+                </a:solidFill>
+                <a:effectLst/>
+                <a:latin typeface="+mn-lt"/>
+                <a:ea typeface="+mn-ea"/>
+                <a:cs typeface="+mn-cs"/>
+              </a:rPr>
+              <a:t>autokorelácia</a:t>
+            </a:r>
+            <a:r>
+              <a:rPr lang="sk-SK" sz="1200" kern="1200" dirty="0">
+                <a:solidFill>
+                  <a:schemeClr val="tx1"/>
+                </a:solidFill>
+                <a:effectLst/>
+                <a:latin typeface="+mn-lt"/>
+                <a:ea typeface="+mn-ea"/>
+                <a:cs typeface="+mn-cs"/>
+              </a:rPr>
+              <a:t> a </a:t>
+            </a:r>
+            <a:r>
+              <a:rPr lang="sk-SK" sz="1200" kern="1200" dirty="0" err="1">
+                <a:solidFill>
+                  <a:schemeClr val="tx1"/>
+                </a:solidFill>
+                <a:effectLst/>
+                <a:latin typeface="+mn-lt"/>
+                <a:ea typeface="+mn-ea"/>
+                <a:cs typeface="+mn-cs"/>
+              </a:rPr>
+              <a:t>heteroskedasticita</a:t>
+            </a:r>
+            <a:r>
+              <a:rPr lang="sk-SK" sz="1200" kern="1200" dirty="0">
+                <a:solidFill>
+                  <a:schemeClr val="tx1"/>
+                </a:solidFill>
+                <a:effectLst/>
+                <a:latin typeface="+mn-lt"/>
+                <a:ea typeface="+mn-ea"/>
+                <a:cs typeface="+mn-cs"/>
+              </a:rPr>
+              <a:t>.</a:t>
+            </a:r>
+          </a:p>
+          <a:p>
+            <a:r>
+              <a:rPr lang="sk-SK" sz="1200" kern="1200" dirty="0">
+                <a:solidFill>
+                  <a:schemeClr val="tx1"/>
+                </a:solidFill>
+                <a:effectLst/>
+                <a:latin typeface="+mn-lt"/>
+                <a:ea typeface="+mn-ea"/>
+                <a:cs typeface="+mn-cs"/>
+              </a:rPr>
+              <a:t>Takto predspracované dáta budú ďalej vhodné ako vstup pre ekonometrické modely a metódy umelej inteligencie.“</a:t>
+            </a:r>
+            <a:r>
+              <a:rPr lang="en-US" sz="1200" kern="1200" dirty="0">
+                <a:solidFill>
+                  <a:schemeClr val="tx1"/>
+                </a:solidFill>
+                <a:effectLst/>
+                <a:latin typeface="+mn-lt"/>
+                <a:ea typeface="+mn-ea"/>
+                <a:cs typeface="+mn-cs"/>
+              </a:rPr>
+              <a:t> </a:t>
+            </a:r>
+            <a:r>
+              <a:rPr lang="en-US" sz="1200" kern="1200" dirty="0" err="1">
+                <a:solidFill>
+                  <a:schemeClr val="tx1"/>
+                </a:solidFill>
+                <a:effectLst/>
+                <a:latin typeface="+mn-lt"/>
+                <a:ea typeface="+mn-ea"/>
+                <a:cs typeface="+mn-cs"/>
+              </a:rPr>
+              <a:t>Logaritmick</a:t>
+            </a:r>
+            <a:r>
+              <a:rPr lang="sk-SK" sz="1200" kern="1200" dirty="0">
+                <a:solidFill>
+                  <a:schemeClr val="tx1"/>
+                </a:solidFill>
+                <a:effectLst/>
+                <a:latin typeface="+mn-lt"/>
+                <a:ea typeface="+mn-ea"/>
+                <a:cs typeface="+mn-cs"/>
+              </a:rPr>
+              <a:t>é výnosy sú: </a:t>
+            </a:r>
+            <a:r>
+              <a:rPr lang="sk-SK" sz="1200" kern="1200" dirty="0" err="1">
+                <a:solidFill>
+                  <a:schemeClr val="tx1"/>
+                </a:solidFill>
+                <a:effectLst/>
+                <a:latin typeface="+mn-lt"/>
+                <a:ea typeface="+mn-ea"/>
+                <a:cs typeface="+mn-cs"/>
+              </a:rPr>
+              <a:t>ln</a:t>
+            </a:r>
+            <a:r>
+              <a:rPr lang="en-US" sz="1200" kern="1200" dirty="0">
+                <a:solidFill>
+                  <a:schemeClr val="tx1"/>
+                </a:solidFill>
+                <a:effectLst/>
+                <a:latin typeface="+mn-lt"/>
+                <a:ea typeface="+mn-ea"/>
+                <a:cs typeface="+mn-cs"/>
+              </a:rPr>
+              <a:t>(</a:t>
+            </a:r>
+            <a:r>
+              <a:rPr lang="en-US" sz="1200" kern="1200" dirty="0" err="1">
+                <a:solidFill>
+                  <a:schemeClr val="tx1"/>
+                </a:solidFill>
+                <a:effectLst/>
+                <a:latin typeface="+mn-lt"/>
+                <a:ea typeface="+mn-ea"/>
+                <a:cs typeface="+mn-cs"/>
+              </a:rPr>
+              <a:t>CLOSEt</a:t>
+            </a:r>
+            <a:r>
+              <a:rPr lang="en-US" sz="1200" kern="1200" dirty="0">
+                <a:solidFill>
+                  <a:schemeClr val="tx1"/>
+                </a:solidFill>
+                <a:effectLst/>
+                <a:latin typeface="+mn-lt"/>
+                <a:ea typeface="+mn-ea"/>
+                <a:cs typeface="+mn-cs"/>
+              </a:rPr>
+              <a:t>) - ln(CLOSEt-1)</a:t>
+            </a:r>
+            <a:endParaRPr lang="sk-SK"/>
+          </a:p>
+          <a:p>
+            <a:endParaRPr lang="sk-SK" dirty="0"/>
+          </a:p>
         </p:txBody>
       </p:sp>
       <p:sp>
@@ -5812,200 +5947,6 @@
               <a:rPr lang="sk-SK" dirty="0"/>
               <a:t> neurónová sieť založená na sekvenčné dáta. Na základe predchádzajúcich dát volatility dokáže predikovať budúcu volatilitu.</a:t>
             </a:r>
-          </a:p>
-          <a:p>
-            <a:endParaRPr lang="sk-SK" dirty="0"/>
-          </a:p>
-          <a:p>
-            <a:r>
-              <a:rPr lang="sk-SK" dirty="0"/>
-              <a:t>Spomenúť:</a:t>
-            </a:r>
-          </a:p>
-          <a:p>
-            <a:r>
-              <a:rPr lang="sk-SK" sz="1200" kern="1200" dirty="0">
-                <a:solidFill>
-                  <a:schemeClr val="tx1"/>
-                </a:solidFill>
-                <a:effectLst/>
-                <a:latin typeface="+mn-lt"/>
-                <a:ea typeface="+mn-ea"/>
-                <a:cs typeface="+mn-cs"/>
-              </a:rPr>
-              <a:t>„Dáta budú transformované na logaritmické výnosy a následne budú analyzované ich vlastnosti ako </a:t>
-            </a:r>
-            <a:r>
-              <a:rPr lang="sk-SK" sz="1200" kern="1200" dirty="0" err="1">
-                <a:solidFill>
-                  <a:schemeClr val="tx1"/>
-                </a:solidFill>
-                <a:effectLst/>
-                <a:latin typeface="+mn-lt"/>
-                <a:ea typeface="+mn-ea"/>
-                <a:cs typeface="+mn-cs"/>
-              </a:rPr>
-              <a:t>stacionarita</a:t>
-            </a:r>
-            <a:r>
-              <a:rPr lang="sk-SK" sz="1200" kern="1200" dirty="0">
-                <a:solidFill>
-                  <a:schemeClr val="tx1"/>
-                </a:solidFill>
-                <a:effectLst/>
-                <a:latin typeface="+mn-lt"/>
-                <a:ea typeface="+mn-ea"/>
-                <a:cs typeface="+mn-cs"/>
-              </a:rPr>
-              <a:t>, </a:t>
-            </a:r>
-            <a:r>
-              <a:rPr lang="sk-SK" sz="1200" kern="1200" dirty="0" err="1">
-                <a:solidFill>
-                  <a:schemeClr val="tx1"/>
-                </a:solidFill>
-                <a:effectLst/>
-                <a:latin typeface="+mn-lt"/>
-                <a:ea typeface="+mn-ea"/>
-                <a:cs typeface="+mn-cs"/>
-              </a:rPr>
-              <a:t>autokorelácia</a:t>
-            </a:r>
-            <a:r>
-              <a:rPr lang="sk-SK" sz="1200" kern="1200" dirty="0">
-                <a:solidFill>
-                  <a:schemeClr val="tx1"/>
-                </a:solidFill>
-                <a:effectLst/>
-                <a:latin typeface="+mn-lt"/>
-                <a:ea typeface="+mn-ea"/>
-                <a:cs typeface="+mn-cs"/>
-              </a:rPr>
-              <a:t> a </a:t>
-            </a:r>
-            <a:r>
-              <a:rPr lang="sk-SK" sz="1200" kern="1200" dirty="0" err="1">
-                <a:solidFill>
-                  <a:schemeClr val="tx1"/>
-                </a:solidFill>
-                <a:effectLst/>
-                <a:latin typeface="+mn-lt"/>
-                <a:ea typeface="+mn-ea"/>
-                <a:cs typeface="+mn-cs"/>
-              </a:rPr>
-              <a:t>heteroskedasticita</a:t>
-            </a:r>
-            <a:r>
-              <a:rPr lang="sk-SK" sz="1200" kern="1200" dirty="0">
-                <a:solidFill>
-                  <a:schemeClr val="tx1"/>
-                </a:solidFill>
-                <a:effectLst/>
-                <a:latin typeface="+mn-lt"/>
-                <a:ea typeface="+mn-ea"/>
-                <a:cs typeface="+mn-cs"/>
-              </a:rPr>
-              <a:t>.</a:t>
-            </a:r>
-          </a:p>
-          <a:p>
-            <a:r>
-              <a:rPr lang="sk-SK" sz="1200" kern="1200" dirty="0">
-                <a:solidFill>
-                  <a:schemeClr val="tx1"/>
-                </a:solidFill>
-                <a:effectLst/>
-                <a:latin typeface="+mn-lt"/>
-                <a:ea typeface="+mn-ea"/>
-                <a:cs typeface="+mn-cs"/>
-              </a:rPr>
-              <a:t>Takto predspracované dáta budú ďalej vhodné ako vstup pre ekonometrické modely a metódy umelej inteligencie.“</a:t>
-            </a:r>
-            <a:r>
-              <a:rPr lang="en-US" sz="1200" kern="1200" dirty="0">
-                <a:solidFill>
-                  <a:schemeClr val="tx1"/>
-                </a:solidFill>
-                <a:effectLst/>
-                <a:latin typeface="+mn-lt"/>
-                <a:ea typeface="+mn-ea"/>
-                <a:cs typeface="+mn-cs"/>
-              </a:rPr>
-              <a:t> </a:t>
-            </a:r>
-            <a:r>
-              <a:rPr lang="en-US" sz="1200" kern="1200" dirty="0" err="1">
-                <a:solidFill>
-                  <a:schemeClr val="tx1"/>
-                </a:solidFill>
-                <a:effectLst/>
-                <a:latin typeface="+mn-lt"/>
-                <a:ea typeface="+mn-ea"/>
-                <a:cs typeface="+mn-cs"/>
-              </a:rPr>
-              <a:t>Logaritmick</a:t>
-            </a:r>
-            <a:r>
-              <a:rPr lang="sk-SK" sz="1200" kern="1200" dirty="0">
-                <a:solidFill>
-                  <a:schemeClr val="tx1"/>
-                </a:solidFill>
-                <a:effectLst/>
-                <a:latin typeface="+mn-lt"/>
-                <a:ea typeface="+mn-ea"/>
-                <a:cs typeface="+mn-cs"/>
-              </a:rPr>
-              <a:t>é výnosy sú: </a:t>
-            </a:r>
-            <a:r>
-              <a:rPr lang="sk-SK" sz="1200" kern="1200" dirty="0" err="1">
-                <a:solidFill>
-                  <a:schemeClr val="tx1"/>
-                </a:solidFill>
-                <a:effectLst/>
-                <a:latin typeface="+mn-lt"/>
-                <a:ea typeface="+mn-ea"/>
-                <a:cs typeface="+mn-cs"/>
-              </a:rPr>
-              <a:t>ln</a:t>
-            </a:r>
-            <a:r>
-              <a:rPr lang="en-US" sz="1200" kern="1200" dirty="0">
-                <a:solidFill>
-                  <a:schemeClr val="tx1"/>
-                </a:solidFill>
-                <a:effectLst/>
-                <a:latin typeface="+mn-lt"/>
-                <a:ea typeface="+mn-ea"/>
-                <a:cs typeface="+mn-cs"/>
-              </a:rPr>
-              <a:t>(</a:t>
-            </a:r>
-            <a:r>
-              <a:rPr lang="en-US" sz="1200" kern="1200" dirty="0" err="1">
-                <a:solidFill>
-                  <a:schemeClr val="tx1"/>
-                </a:solidFill>
-                <a:effectLst/>
-                <a:latin typeface="+mn-lt"/>
-                <a:ea typeface="+mn-ea"/>
-                <a:cs typeface="+mn-cs"/>
-              </a:rPr>
-              <a:t>CLOSEt</a:t>
-            </a:r>
-            <a:r>
-              <a:rPr lang="en-US" sz="1200" kern="1200" dirty="0">
-                <a:solidFill>
-                  <a:schemeClr val="tx1"/>
-                </a:solidFill>
-                <a:effectLst/>
-                <a:latin typeface="+mn-lt"/>
-                <a:ea typeface="+mn-ea"/>
-                <a:cs typeface="+mn-cs"/>
-              </a:rPr>
-              <a:t>) - ln(CLOSEt-1)</a:t>
-            </a:r>
-            <a:endParaRPr lang="sk-SK" dirty="0"/>
           </a:p>
         </p:txBody>
       </p:sp>
@@ -6457,7 +6398,7 @@
           <a:p>
             <a:fld id="{02AC24A9-CCB6-4F8D-B8DB-C2F3692CFA5A}" type="datetimeFigureOut">
               <a:rPr lang="en-US" smtClean="0"/>
-              <a:t>6/21/2026</a:t>
+              <a:t>6/24/2026</a:t>
             </a:fld>
             <a:endParaRPr lang="en-US" dirty="0"/>
           </a:p>
@@ -6828,7 +6769,7 @@
           <a:p>
             <a:fld id="{02AC24A9-CCB6-4F8D-B8DB-C2F3692CFA5A}" type="datetimeFigureOut">
               <a:rPr lang="en-US" smtClean="0"/>
-              <a:t>6/21/2026</a:t>
+              <a:t>6/24/2026</a:t>
             </a:fld>
             <a:endParaRPr lang="en-US" dirty="0"/>
           </a:p>
@@ -7038,7 +6979,7 @@
           <a:p>
             <a:fld id="{02AC24A9-CCB6-4F8D-B8DB-C2F3692CFA5A}" type="datetimeFigureOut">
               <a:rPr lang="en-US" smtClean="0"/>
-              <a:t>6/21/2026</a:t>
+              <a:t>6/24/2026</a:t>
             </a:fld>
             <a:endParaRPr lang="en-US" dirty="0"/>
           </a:p>
@@ -7510,7 +7451,7 @@
           <a:p>
             <a:fld id="{02AC24A9-CCB6-4F8D-B8DB-C2F3692CFA5A}" type="datetimeFigureOut">
               <a:rPr lang="en-US" smtClean="0"/>
-              <a:t>6/21/2026</a:t>
+              <a:t>6/24/2026</a:t>
             </a:fld>
             <a:endParaRPr lang="en-US" dirty="0"/>
           </a:p>
@@ -7965,7 +7906,7 @@
           <a:p>
             <a:fld id="{02AC24A9-CCB6-4F8D-B8DB-C2F3692CFA5A}" type="datetimeFigureOut">
               <a:rPr lang="en-US" smtClean="0"/>
-              <a:t>6/21/2026</a:t>
+              <a:t>6/24/2026</a:t>
             </a:fld>
             <a:endParaRPr lang="en-US" dirty="0"/>
           </a:p>
@@ -8500,7 +8441,7 @@
           <a:p>
             <a:fld id="{02AC24A9-CCB6-4F8D-B8DB-C2F3692CFA5A}" type="datetimeFigureOut">
               <a:rPr lang="en-US" smtClean="0"/>
-              <a:t>6/21/2026</a:t>
+              <a:t>6/24/2026</a:t>
             </a:fld>
             <a:endParaRPr lang="en-US" dirty="0"/>
           </a:p>
@@ -9202,7 +9143,7 @@
           <a:p>
             <a:fld id="{02AC24A9-CCB6-4F8D-B8DB-C2F3692CFA5A}" type="datetimeFigureOut">
               <a:rPr lang="en-US" smtClean="0"/>
-              <a:t>6/21/2026</a:t>
+              <a:t>6/24/2026</a:t>
             </a:fld>
             <a:endParaRPr lang="en-US" dirty="0"/>
           </a:p>
@@ -9532,7 +9473,7 @@
           <a:p>
             <a:fld id="{02AC24A9-CCB6-4F8D-B8DB-C2F3692CFA5A}" type="datetimeFigureOut">
               <a:rPr lang="en-US" smtClean="0"/>
-              <a:t>6/21/2026</a:t>
+              <a:t>6/24/2026</a:t>
             </a:fld>
             <a:endParaRPr lang="en-US" dirty="0"/>
           </a:p>
@@ -9645,7 +9586,7 @@
           <a:p>
             <a:fld id="{02AC24A9-CCB6-4F8D-B8DB-C2F3692CFA5A}" type="datetimeFigureOut">
               <a:rPr lang="en-US" smtClean="0"/>
-              <a:t>6/21/2026</a:t>
+              <a:t>6/24/2026</a:t>
             </a:fld>
             <a:endParaRPr lang="en-US" dirty="0"/>
           </a:p>
@@ -10142,7 +10083,7 @@
           <a:p>
             <a:fld id="{02AC24A9-CCB6-4F8D-B8DB-C2F3692CFA5A}" type="datetimeFigureOut">
               <a:rPr lang="en-US" smtClean="0"/>
-              <a:t>6/21/2026</a:t>
+              <a:t>6/24/2026</a:t>
             </a:fld>
             <a:endParaRPr lang="en-US" dirty="0"/>
           </a:p>
@@ -10621,7 +10562,7 @@
           <a:p>
             <a:fld id="{02AC24A9-CCB6-4F8D-B8DB-C2F3692CFA5A}" type="datetimeFigureOut">
               <a:rPr lang="en-US" smtClean="0"/>
-              <a:t>6/21/2026</a:t>
+              <a:t>6/24/2026</a:t>
             </a:fld>
             <a:endParaRPr lang="en-US" dirty="0"/>
           </a:p>
@@ -10864,7 +10805,7 @@
           <a:p>
             <a:fld id="{02AC24A9-CCB6-4F8D-B8DB-C2F3692CFA5A}" type="datetimeFigureOut">
               <a:rPr lang="en-US" smtClean="0"/>
-              <a:t>6/21/2026</a:t>
+              <a:t>6/24/2026</a:t>
             </a:fld>
             <a:endParaRPr lang="en-US" dirty="0"/>
           </a:p>
@@ -11618,7 +11559,7 @@
           <a:p>
             <a:r>
               <a:rPr lang="sk-SK" sz="1800" dirty="0"/>
-              <a:t>Natrénovať modely strojového učenia,</a:t>
+              <a:t>Natrénovať modely strojového a hlbokého učenia,</a:t>
             </a:r>
           </a:p>
           <a:p>
@@ -11714,7 +11655,7 @@
         <p:spPr>
           <a:xfrm>
             <a:off x="1115568" y="2478023"/>
-            <a:ext cx="10650862" cy="3698489"/>
+            <a:ext cx="10650862" cy="3831337"/>
           </a:xfrm>
         </p:spPr>
         <p:txBody>
@@ -11746,7 +11687,7 @@
             </a:r>
             <a:r>
               <a:rPr lang="sk-SK" sz="2000" dirty="0"/>
-              <a:t>Empirické porovnanie modelov strojového učenia s ekonometrickými riešeniami,</a:t>
+              <a:t>Definícia metodiky pre identifikáciu vzorov v časových radoch akciových trhov s dôrazom na metódy umelej inteligencie,</a:t>
             </a:r>
           </a:p>
           <a:p>
@@ -11878,7 +11819,7 @@
             </a:r>
             <a:r>
               <a:rPr lang="sk-SK" sz="2000" dirty="0"/>
-              <a:t>Definícia metodiky pre identifikáciu vzorov v časových radoch akciových trhov s dôrazom na metódy umelej inteligencie,</a:t>
+              <a:t>Empirické porovnanie modelov strojového a hlbokého učenia s ekonometrickými metódami,</a:t>
             </a:r>
           </a:p>
           <a:p>
@@ -12225,7 +12166,7 @@
             <p:ph idx="1"/>
             <p:extLst>
               <p:ext uri="{D42A27DB-BD31-4B8C-83A1-F6EECF244321}">
-                <p14:modId xmlns:p14="http://schemas.microsoft.com/office/powerpoint/2010/main" val="4249491686"/>
+                <p14:modId xmlns:p14="http://schemas.microsoft.com/office/powerpoint/2010/main" val="3087682289"/>
               </p:ext>
             </p:extLst>
           </p:nvPr>
@@ -13003,7 +12944,7 @@
           <a:p>
             <a:r>
               <a:rPr lang="sk-SK" sz="1800" dirty="0"/>
-              <a:t>Identifikácia faktorov vplývajúcich na volatilitu trhov.</a:t>
+              <a:t>Identifikácia faktorov vplývajúcich na dynamiku trhov.</a:t>
             </a:r>
           </a:p>
         </p:txBody>

</xml_diff>

<commit_message>
Analýza súčasného stavu článok init
Dáta OpenAlex, Semantic Scholar
Draft pojmov
</commit_message>
<xml_diff>
--- a/Identifikácia vzorov v časových radoch pre komparáciu volatility.pptx
+++ b/Identifikácia vzorov v časových radoch pre komparáciu volatility.pptx
@@ -4761,7 +4761,7 @@
           <a:p>
             <a:fld id="{AD9B504B-8E04-47AE-BBD5-0260BCE63BC0}" type="datetimeFigureOut">
               <a:rPr lang="sk-SK" smtClean="0"/>
-              <a:t>24. 6. 2026</a:t>
+              <a:t>25. 6. 2026</a:t>
             </a:fld>
             <a:endParaRPr lang="sk-SK"/>
           </a:p>
@@ -6398,7 +6398,7 @@
           <a:p>
             <a:fld id="{02AC24A9-CCB6-4F8D-B8DB-C2F3692CFA5A}" type="datetimeFigureOut">
               <a:rPr lang="en-US" smtClean="0"/>
-              <a:t>6/24/2026</a:t>
+              <a:t>6/25/2026</a:t>
             </a:fld>
             <a:endParaRPr lang="en-US" dirty="0"/>
           </a:p>
@@ -6769,7 +6769,7 @@
           <a:p>
             <a:fld id="{02AC24A9-CCB6-4F8D-B8DB-C2F3692CFA5A}" type="datetimeFigureOut">
               <a:rPr lang="en-US" smtClean="0"/>
-              <a:t>6/24/2026</a:t>
+              <a:t>6/25/2026</a:t>
             </a:fld>
             <a:endParaRPr lang="en-US" dirty="0"/>
           </a:p>
@@ -6979,7 +6979,7 @@
           <a:p>
             <a:fld id="{02AC24A9-CCB6-4F8D-B8DB-C2F3692CFA5A}" type="datetimeFigureOut">
               <a:rPr lang="en-US" smtClean="0"/>
-              <a:t>6/24/2026</a:t>
+              <a:t>6/25/2026</a:t>
             </a:fld>
             <a:endParaRPr lang="en-US" dirty="0"/>
           </a:p>
@@ -7451,7 +7451,7 @@
           <a:p>
             <a:fld id="{02AC24A9-CCB6-4F8D-B8DB-C2F3692CFA5A}" type="datetimeFigureOut">
               <a:rPr lang="en-US" smtClean="0"/>
-              <a:t>6/24/2026</a:t>
+              <a:t>6/25/2026</a:t>
             </a:fld>
             <a:endParaRPr lang="en-US" dirty="0"/>
           </a:p>
@@ -7906,7 +7906,7 @@
           <a:p>
             <a:fld id="{02AC24A9-CCB6-4F8D-B8DB-C2F3692CFA5A}" type="datetimeFigureOut">
               <a:rPr lang="en-US" smtClean="0"/>
-              <a:t>6/24/2026</a:t>
+              <a:t>6/25/2026</a:t>
             </a:fld>
             <a:endParaRPr lang="en-US" dirty="0"/>
           </a:p>
@@ -8441,7 +8441,7 @@
           <a:p>
             <a:fld id="{02AC24A9-CCB6-4F8D-B8DB-C2F3692CFA5A}" type="datetimeFigureOut">
               <a:rPr lang="en-US" smtClean="0"/>
-              <a:t>6/24/2026</a:t>
+              <a:t>6/25/2026</a:t>
             </a:fld>
             <a:endParaRPr lang="en-US" dirty="0"/>
           </a:p>
@@ -9143,7 +9143,7 @@
           <a:p>
             <a:fld id="{02AC24A9-CCB6-4F8D-B8DB-C2F3692CFA5A}" type="datetimeFigureOut">
               <a:rPr lang="en-US" smtClean="0"/>
-              <a:t>6/24/2026</a:t>
+              <a:t>6/25/2026</a:t>
             </a:fld>
             <a:endParaRPr lang="en-US" dirty="0"/>
           </a:p>
@@ -9473,7 +9473,7 @@
           <a:p>
             <a:fld id="{02AC24A9-CCB6-4F8D-B8DB-C2F3692CFA5A}" type="datetimeFigureOut">
               <a:rPr lang="en-US" smtClean="0"/>
-              <a:t>6/24/2026</a:t>
+              <a:t>6/25/2026</a:t>
             </a:fld>
             <a:endParaRPr lang="en-US" dirty="0"/>
           </a:p>
@@ -9586,7 +9586,7 @@
           <a:p>
             <a:fld id="{02AC24A9-CCB6-4F8D-B8DB-C2F3692CFA5A}" type="datetimeFigureOut">
               <a:rPr lang="en-US" smtClean="0"/>
-              <a:t>6/24/2026</a:t>
+              <a:t>6/25/2026</a:t>
             </a:fld>
             <a:endParaRPr lang="en-US" dirty="0"/>
           </a:p>
@@ -10083,7 +10083,7 @@
           <a:p>
             <a:fld id="{02AC24A9-CCB6-4F8D-B8DB-C2F3692CFA5A}" type="datetimeFigureOut">
               <a:rPr lang="en-US" smtClean="0"/>
-              <a:t>6/24/2026</a:t>
+              <a:t>6/25/2026</a:t>
             </a:fld>
             <a:endParaRPr lang="en-US" dirty="0"/>
           </a:p>
@@ -10562,7 +10562,7 @@
           <a:p>
             <a:fld id="{02AC24A9-CCB6-4F8D-B8DB-C2F3692CFA5A}" type="datetimeFigureOut">
               <a:rPr lang="en-US" smtClean="0"/>
-              <a:t>6/24/2026</a:t>
+              <a:t>6/25/2026</a:t>
             </a:fld>
             <a:endParaRPr lang="en-US" dirty="0"/>
           </a:p>
@@ -10805,7 +10805,7 @@
           <a:p>
             <a:fld id="{02AC24A9-CCB6-4F8D-B8DB-C2F3692CFA5A}" type="datetimeFigureOut">
               <a:rPr lang="en-US" smtClean="0"/>
-              <a:t>6/24/2026</a:t>
+              <a:t>6/25/2026</a:t>
             </a:fld>
             <a:endParaRPr lang="en-US" dirty="0"/>
           </a:p>
@@ -12606,7 +12606,7 @@
         <p:spPr/>
         <p:txBody>
           <a:bodyPr>
-            <a:normAutofit lnSpcReduction="10000"/>
+            <a:normAutofit/>
           </a:bodyPr>
           <a:lstStyle/>
           <a:p>
@@ -12701,33 +12701,6 @@
             <a:r>
               <a:rPr lang="sk-SK" sz="1800" dirty="0"/>
               <a:t>.</a:t>
-            </a:r>
-          </a:p>
-          <a:p>
-            <a:pPr marL="0" indent="0">
-              <a:buNone/>
-            </a:pPr>
-            <a:r>
-              <a:rPr lang="sk-SK" sz="1800" b="1" dirty="0">
-                <a:effectLst>
-                  <a:outerShdw blurRad="38100" dist="38100" dir="2700000" algn="tl">
-                    <a:srgbClr val="000000">
-                      <a:alpha val="43137"/>
-                    </a:srgbClr>
-                  </a:outerShdw>
-                </a:effectLst>
-              </a:rPr>
-              <a:t>Trénovanie</a:t>
-            </a:r>
-          </a:p>
-          <a:p>
-            <a:r>
-              <a:rPr lang="sk-SK" sz="1800" dirty="0" err="1"/>
-              <a:t>Rolling-window</a:t>
-            </a:r>
-            <a:r>
-              <a:rPr lang="sk-SK" sz="1800" dirty="0"/>
-              <a:t> prístup.</a:t>
             </a:r>
           </a:p>
           <a:p>

</xml_diff>